<commit_message>
Final Changes for final presentation
</commit_message>
<xml_diff>
--- a/submission/10_presentation.pptx
+++ b/submission/10_presentation.pptx
@@ -5,21 +5,24 @@
     <p:sldMasterId id="2147483648" r:id="rId1"/>
   </p:sldMasterIdLst>
   <p:notesMasterIdLst>
-    <p:notesMasterId r:id="rId14"/>
+    <p:notesMasterId r:id="rId17"/>
   </p:notesMasterIdLst>
   <p:sldIdLst>
     <p:sldId id="256" r:id="rId2"/>
     <p:sldId id="257" r:id="rId3"/>
     <p:sldId id="258" r:id="rId4"/>
     <p:sldId id="259" r:id="rId5"/>
-    <p:sldId id="260" r:id="rId6"/>
-    <p:sldId id="261" r:id="rId7"/>
-    <p:sldId id="262" r:id="rId8"/>
-    <p:sldId id="263" r:id="rId9"/>
-    <p:sldId id="264" r:id="rId10"/>
+    <p:sldId id="268" r:id="rId6"/>
+    <p:sldId id="260" r:id="rId7"/>
+    <p:sldId id="261" r:id="rId8"/>
+    <p:sldId id="262" r:id="rId9"/>
+    <p:sldId id="263" r:id="rId10"/>
     <p:sldId id="265" r:id="rId11"/>
-    <p:sldId id="266" r:id="rId12"/>
-    <p:sldId id="267" r:id="rId13"/>
+    <p:sldId id="269" r:id="rId12"/>
+    <p:sldId id="270" r:id="rId13"/>
+    <p:sldId id="264" r:id="rId14"/>
+    <p:sldId id="266" r:id="rId15"/>
+    <p:sldId id="267" r:id="rId16"/>
   </p:sldIdLst>
   <p:sldSz cx="9144000" cy="5143500" type="screen16x9"/>
   <p:notesSz cx="5143500" cy="9144000"/>
@@ -116,6 +119,33 @@
     </a:lvl9pPr>
   </p:defaultTextStyle>
   <p:extLst>
+    <p:ext uri="{521415D9-36F7-43E2-AB2F-B90AF26B5E84}">
+      <p14:sectionLst xmlns:p14="http://schemas.microsoft.com/office/powerpoint/2010/main">
+        <p14:section name="Default Section" id="{9FA82741-87B1-4487-9A65-566CDA1C968F}">
+          <p14:sldIdLst>
+            <p14:sldId id="256"/>
+            <p14:sldId id="257"/>
+            <p14:sldId id="258"/>
+            <p14:sldId id="259"/>
+          </p14:sldIdLst>
+        </p14:section>
+        <p14:section name="Untitled Section" id="{A1A5B544-46F6-47D6-8228-B3E215893F69}">
+          <p14:sldIdLst>
+            <p14:sldId id="268"/>
+            <p14:sldId id="260"/>
+            <p14:sldId id="261"/>
+            <p14:sldId id="262"/>
+            <p14:sldId id="263"/>
+            <p14:sldId id="265"/>
+            <p14:sldId id="269"/>
+            <p14:sldId id="270"/>
+            <p14:sldId id="264"/>
+            <p14:sldId id="266"/>
+            <p14:sldId id="267"/>
+          </p14:sldIdLst>
+        </p14:section>
+      </p14:sectionLst>
+    </p:ext>
     <p:ext uri="{EFAFB233-063F-42B5-8137-9DF3F51BA10A}">
       <p15:sldGuideLst xmlns:p15="http://schemas.microsoft.com/office/powerpoint/2012/main"/>
     </p:ext>
@@ -123,12 +153,20 @@
 </p:presentation>
 </file>
 
+<file path=ppt/revisionInfo.xml><?xml version="1.0" encoding="utf-8"?>
+<p1510:revInfo xmlns:a="http://schemas.openxmlformats.org/drawingml/2006/main" xmlns:r="http://schemas.openxmlformats.org/officeDocument/2006/relationships" xmlns:p1510="http://schemas.microsoft.com/office/powerpoint/2015/10/main">
+  <p1510:revLst>
+    <p1510:client id="{D7048AC8-312E-4216-BCE0-2450962C18D2}" v="1" dt="2026-04-28T17:23:07.228"/>
+  </p1510:revLst>
+</p1510:revInfo>
+</file>
+
 <file path=ppt/changesInfos/changesInfo1.xml><?xml version="1.0" encoding="utf-8"?>
 <pc:chgInfo xmlns:a="http://schemas.openxmlformats.org/drawingml/2006/main" xmlns:r="http://schemas.openxmlformats.org/officeDocument/2006/relationships" xmlns:ac="http://schemas.microsoft.com/office/drawing/2013/main/command" xmlns:pc="http://schemas.microsoft.com/office/powerpoint/2013/main/command">
   <pc:docChgLst>
     <pc:chgData name="Mi Nguyen" userId="9f5fd27d9273936d" providerId="LiveId" clId="{AC88EA9E-70A4-4E13-82F5-A44B617434F3}"/>
-    <pc:docChg chg="undo custSel modSld">
-      <pc:chgData name="Mi Nguyen" userId="9f5fd27d9273936d" providerId="LiveId" clId="{AC88EA9E-70A4-4E13-82F5-A44B617434F3}" dt="2026-04-28T15:28:30.875" v="16" actId="1076"/>
+    <pc:docChg chg="undo custSel addSld delSld modSld sldOrd addSection modSection">
+      <pc:chgData name="Mi Nguyen" userId="9f5fd27d9273936d" providerId="LiveId" clId="{AC88EA9E-70A4-4E13-82F5-A44B617434F3}" dt="2026-04-28T17:38:25.291" v="353" actId="1076"/>
       <pc:docMkLst>
         <pc:docMk/>
       </pc:docMkLst>
@@ -156,17 +194,63 @@
         </pc:spChg>
       </pc:sldChg>
       <pc:sldChg chg="modSp mod">
-        <pc:chgData name="Mi Nguyen" userId="9f5fd27d9273936d" providerId="LiveId" clId="{AC88EA9E-70A4-4E13-82F5-A44B617434F3}" dt="2026-04-28T15:28:30.875" v="16" actId="1076"/>
+        <pc:chgData name="Mi Nguyen" userId="9f5fd27d9273936d" providerId="LiveId" clId="{AC88EA9E-70A4-4E13-82F5-A44B617434F3}" dt="2026-04-28T16:19:24.860" v="126" actId="20577"/>
+        <pc:sldMkLst>
+          <pc:docMk/>
+          <pc:sldMk cId="0" sldId="258"/>
+        </pc:sldMkLst>
+        <pc:spChg chg="mod">
+          <ac:chgData name="Mi Nguyen" userId="9f5fd27d9273936d" providerId="LiveId" clId="{AC88EA9E-70A4-4E13-82F5-A44B617434F3}" dt="2026-04-28T16:05:14.019" v="121" actId="5793"/>
+          <ac:spMkLst>
+            <pc:docMk/>
+            <pc:sldMk cId="0" sldId="258"/>
+            <ac:spMk id="6" creationId="{00000000-0000-0000-0000-000000000000}"/>
+          </ac:spMkLst>
+        </pc:spChg>
+        <pc:spChg chg="mod">
+          <ac:chgData name="Mi Nguyen" userId="9f5fd27d9273936d" providerId="LiveId" clId="{AC88EA9E-70A4-4E13-82F5-A44B617434F3}" dt="2026-04-28T16:19:24.860" v="126" actId="20577"/>
+          <ac:spMkLst>
+            <pc:docMk/>
+            <pc:sldMk cId="0" sldId="258"/>
+            <ac:spMk id="9" creationId="{00000000-0000-0000-0000-000000000000}"/>
+          </ac:spMkLst>
+        </pc:spChg>
+      </pc:sldChg>
+      <pc:sldChg chg="modSp mod">
+        <pc:chgData name="Mi Nguyen" userId="9f5fd27d9273936d" providerId="LiveId" clId="{AC88EA9E-70A4-4E13-82F5-A44B617434F3}" dt="2026-04-28T16:57:35.325" v="195" actId="20577"/>
+        <pc:sldMkLst>
+          <pc:docMk/>
+          <pc:sldMk cId="0" sldId="260"/>
+        </pc:sldMkLst>
+        <pc:spChg chg="mod">
+          <ac:chgData name="Mi Nguyen" userId="9f5fd27d9273936d" providerId="LiveId" clId="{AC88EA9E-70A4-4E13-82F5-A44B617434F3}" dt="2026-04-28T16:57:35.325" v="195" actId="20577"/>
+          <ac:spMkLst>
+            <pc:docMk/>
+            <pc:sldMk cId="0" sldId="260"/>
+            <ac:spMk id="22" creationId="{00000000-0000-0000-0000-000000000000}"/>
+          </ac:spMkLst>
+        </pc:spChg>
+      </pc:sldChg>
+      <pc:sldChg chg="addSp modSp mod">
+        <pc:chgData name="Mi Nguyen" userId="9f5fd27d9273936d" providerId="LiveId" clId="{AC88EA9E-70A4-4E13-82F5-A44B617434F3}" dt="2026-04-28T17:23:32.154" v="290" actId="14100"/>
         <pc:sldMkLst>
           <pc:docMk/>
           <pc:sldMk cId="0" sldId="261"/>
         </pc:sldMkLst>
         <pc:spChg chg="mod">
-          <ac:chgData name="Mi Nguyen" userId="9f5fd27d9273936d" providerId="LiveId" clId="{AC88EA9E-70A4-4E13-82F5-A44B617434F3}" dt="2026-04-28T15:27:32.596" v="7" actId="1076"/>
+          <ac:chgData name="Mi Nguyen" userId="9f5fd27d9273936d" providerId="LiveId" clId="{AC88EA9E-70A4-4E13-82F5-A44B617434F3}" dt="2026-04-28T16:58:54.054" v="202" actId="1076"/>
           <ac:spMkLst>
             <pc:docMk/>
             <pc:sldMk cId="0" sldId="261"/>
             <ac:spMk id="6" creationId="{00000000-0000-0000-0000-000000000000}"/>
+          </ac:spMkLst>
+        </pc:spChg>
+        <pc:spChg chg="mod">
+          <ac:chgData name="Mi Nguyen" userId="9f5fd27d9273936d" providerId="LiveId" clId="{AC88EA9E-70A4-4E13-82F5-A44B617434F3}" dt="2026-04-28T16:58:54.054" v="202" actId="1076"/>
+          <ac:spMkLst>
+            <pc:docMk/>
+            <pc:sldMk cId="0" sldId="261"/>
+            <ac:spMk id="7" creationId="{00000000-0000-0000-0000-000000000000}"/>
           </ac:spMkLst>
         </pc:spChg>
         <pc:spChg chg="mod">
@@ -178,7 +262,15 @@
           </ac:spMkLst>
         </pc:spChg>
         <pc:spChg chg="mod">
-          <ac:chgData name="Mi Nguyen" userId="9f5fd27d9273936d" providerId="LiveId" clId="{AC88EA9E-70A4-4E13-82F5-A44B617434F3}" dt="2026-04-28T15:27:46.918" v="10" actId="1076"/>
+          <ac:chgData name="Mi Nguyen" userId="9f5fd27d9273936d" providerId="LiveId" clId="{AC88EA9E-70A4-4E13-82F5-A44B617434F3}" dt="2026-04-28T16:59:44.886" v="210" actId="14100"/>
+          <ac:spMkLst>
+            <pc:docMk/>
+            <pc:sldMk cId="0" sldId="261"/>
+            <ac:spMk id="10" creationId="{00000000-0000-0000-0000-000000000000}"/>
+          </ac:spMkLst>
+        </pc:spChg>
+        <pc:spChg chg="mod">
+          <ac:chgData name="Mi Nguyen" userId="9f5fd27d9273936d" providerId="LiveId" clId="{AC88EA9E-70A4-4E13-82F5-A44B617434F3}" dt="2026-04-28T16:59:14.467" v="206" actId="1076"/>
           <ac:spMkLst>
             <pc:docMk/>
             <pc:sldMk cId="0" sldId="261"/>
@@ -186,7 +278,15 @@
           </ac:spMkLst>
         </pc:spChg>
         <pc:spChg chg="mod">
-          <ac:chgData name="Mi Nguyen" userId="9f5fd27d9273936d" providerId="LiveId" clId="{AC88EA9E-70A4-4E13-82F5-A44B617434F3}" dt="2026-04-28T15:27:42.808" v="9" actId="1076"/>
+          <ac:chgData name="Mi Nguyen" userId="9f5fd27d9273936d" providerId="LiveId" clId="{AC88EA9E-70A4-4E13-82F5-A44B617434F3}" dt="2026-04-28T16:59:32.707" v="208" actId="14100"/>
+          <ac:spMkLst>
+            <pc:docMk/>
+            <pc:sldMk cId="0" sldId="261"/>
+            <ac:spMk id="12" creationId="{00000000-0000-0000-0000-000000000000}"/>
+          </ac:spMkLst>
+        </pc:spChg>
+        <pc:spChg chg="mod">
+          <ac:chgData name="Mi Nguyen" userId="9f5fd27d9273936d" providerId="LiveId" clId="{AC88EA9E-70A4-4E13-82F5-A44B617434F3}" dt="2026-04-28T16:58:58.810" v="203" actId="14100"/>
           <ac:spMkLst>
             <pc:docMk/>
             <pc:sldMk cId="0" sldId="261"/>
@@ -194,7 +294,15 @@
           </ac:spMkLst>
         </pc:spChg>
         <pc:spChg chg="mod">
-          <ac:chgData name="Mi Nguyen" userId="9f5fd27d9273936d" providerId="LiveId" clId="{AC88EA9E-70A4-4E13-82F5-A44B617434F3}" dt="2026-04-28T15:27:54.442" v="11" actId="1076"/>
+          <ac:chgData name="Mi Nguyen" userId="9f5fd27d9273936d" providerId="LiveId" clId="{AC88EA9E-70A4-4E13-82F5-A44B617434F3}" dt="2026-04-28T16:58:38.651" v="200" actId="1076"/>
+          <ac:spMkLst>
+            <pc:docMk/>
+            <pc:sldMk cId="0" sldId="261"/>
+            <ac:spMk id="14" creationId="{00000000-0000-0000-0000-000000000000}"/>
+          </ac:spMkLst>
+        </pc:spChg>
+        <pc:spChg chg="mod">
+          <ac:chgData name="Mi Nguyen" userId="9f5fd27d9273936d" providerId="LiveId" clId="{AC88EA9E-70A4-4E13-82F5-A44B617434F3}" dt="2026-04-28T16:58:43.921" v="201" actId="1076"/>
           <ac:spMkLst>
             <pc:docMk/>
             <pc:sldMk cId="0" sldId="261"/>
@@ -202,7 +310,7 @@
           </ac:spMkLst>
         </pc:spChg>
         <pc:spChg chg="mod">
-          <ac:chgData name="Mi Nguyen" userId="9f5fd27d9273936d" providerId="LiveId" clId="{AC88EA9E-70A4-4E13-82F5-A44B617434F3}" dt="2026-04-28T15:28:30.875" v="16" actId="1076"/>
+          <ac:chgData name="Mi Nguyen" userId="9f5fd27d9273936d" providerId="LiveId" clId="{AC88EA9E-70A4-4E13-82F5-A44B617434F3}" dt="2026-04-28T17:22:57.677" v="283" actId="14100"/>
           <ac:spMkLst>
             <pc:docMk/>
             <pc:sldMk cId="0" sldId="261"/>
@@ -210,11 +318,27 @@
           </ac:spMkLst>
         </pc:spChg>
         <pc:spChg chg="mod">
-          <ac:chgData name="Mi Nguyen" userId="9f5fd27d9273936d" providerId="LiveId" clId="{AC88EA9E-70A4-4E13-82F5-A44B617434F3}" dt="2026-04-28T15:28:10.329" v="14" actId="1076"/>
+          <ac:chgData name="Mi Nguyen" userId="9f5fd27d9273936d" providerId="LiveId" clId="{AC88EA9E-70A4-4E13-82F5-A44B617434F3}" dt="2026-04-28T17:22:52.406" v="282" actId="1076"/>
           <ac:spMkLst>
             <pc:docMk/>
             <pc:sldMk cId="0" sldId="261"/>
             <ac:spMk id="17" creationId="{00000000-0000-0000-0000-000000000000}"/>
+          </ac:spMkLst>
+        </pc:spChg>
+        <pc:spChg chg="mod">
+          <ac:chgData name="Mi Nguyen" userId="9f5fd27d9273936d" providerId="LiveId" clId="{AC88EA9E-70A4-4E13-82F5-A44B617434F3}" dt="2026-04-28T17:23:32.154" v="290" actId="14100"/>
+          <ac:spMkLst>
+            <pc:docMk/>
+            <pc:sldMk cId="0" sldId="261"/>
+            <ac:spMk id="18" creationId="{00000000-0000-0000-0000-000000000000}"/>
+          </ac:spMkLst>
+        </pc:spChg>
+        <pc:spChg chg="mod">
+          <ac:chgData name="Mi Nguyen" userId="9f5fd27d9273936d" providerId="LiveId" clId="{AC88EA9E-70A4-4E13-82F5-A44B617434F3}" dt="2026-04-28T17:23:22.093" v="288" actId="14100"/>
+          <ac:spMkLst>
+            <pc:docMk/>
+            <pc:sldMk cId="0" sldId="261"/>
+            <ac:spMk id="19" creationId="{00000000-0000-0000-0000-000000000000}"/>
           </ac:spMkLst>
         </pc:spChg>
         <pc:spChg chg="mod">
@@ -225,9 +349,17 @@
             <ac:spMk id="20" creationId="{00000000-0000-0000-0000-000000000000}"/>
           </ac:spMkLst>
         </pc:spChg>
+        <pc:spChg chg="add mod">
+          <ac:chgData name="Mi Nguyen" userId="9f5fd27d9273936d" providerId="LiveId" clId="{AC88EA9E-70A4-4E13-82F5-A44B617434F3}" dt="2026-04-28T17:23:18.164" v="287" actId="14100"/>
+          <ac:spMkLst>
+            <pc:docMk/>
+            <pc:sldMk cId="0" sldId="261"/>
+            <ac:spMk id="21" creationId="{065B1783-2806-9226-2026-E44A1B6DA31C}"/>
+          </ac:spMkLst>
+        </pc:spChg>
       </pc:sldChg>
-      <pc:sldChg chg="modSp mod">
-        <pc:chgData name="Mi Nguyen" userId="9f5fd27d9273936d" providerId="LiveId" clId="{AC88EA9E-70A4-4E13-82F5-A44B617434F3}" dt="2026-04-28T15:26:51.570" v="5" actId="1076"/>
+      <pc:sldChg chg="addSp modSp mod ord">
+        <pc:chgData name="Mi Nguyen" userId="9f5fd27d9273936d" providerId="LiveId" clId="{AC88EA9E-70A4-4E13-82F5-A44B617434F3}" dt="2026-04-28T17:34:25.094" v="292"/>
         <pc:sldMkLst>
           <pc:docMk/>
           <pc:sldMk cId="0" sldId="264"/>
@@ -248,6 +380,471 @@
             <ac:spMk id="6" creationId="{00000000-0000-0000-0000-000000000000}"/>
           </ac:spMkLst>
         </pc:spChg>
+        <pc:picChg chg="add mod">
+          <ac:chgData name="Mi Nguyen" userId="9f5fd27d9273936d" providerId="LiveId" clId="{AC88EA9E-70A4-4E13-82F5-A44B617434F3}" dt="2026-04-28T16:45:17.757" v="154" actId="27614"/>
+          <ac:picMkLst>
+            <pc:docMk/>
+            <pc:sldMk cId="0" sldId="264"/>
+            <ac:picMk id="8" creationId="{A838B6D8-3658-5004-D0DF-C734115B0206}"/>
+          </ac:picMkLst>
+        </pc:picChg>
+      </pc:sldChg>
+      <pc:sldChg chg="modSp mod">
+        <pc:chgData name="Mi Nguyen" userId="9f5fd27d9273936d" providerId="LiveId" clId="{AC88EA9E-70A4-4E13-82F5-A44B617434F3}" dt="2026-04-28T16:41:40.141" v="151" actId="20577"/>
+        <pc:sldMkLst>
+          <pc:docMk/>
+          <pc:sldMk cId="0" sldId="265"/>
+        </pc:sldMkLst>
+        <pc:spChg chg="mod">
+          <ac:chgData name="Mi Nguyen" userId="9f5fd27d9273936d" providerId="LiveId" clId="{AC88EA9E-70A4-4E13-82F5-A44B617434F3}" dt="2026-04-28T16:41:40.141" v="151" actId="20577"/>
+          <ac:spMkLst>
+            <pc:docMk/>
+            <pc:sldMk cId="0" sldId="265"/>
+            <ac:spMk id="4" creationId="{00000000-0000-0000-0000-000000000000}"/>
+          </ac:spMkLst>
+        </pc:spChg>
+      </pc:sldChg>
+      <pc:sldChg chg="addSp delSp modSp mod">
+        <pc:chgData name="Mi Nguyen" userId="9f5fd27d9273936d" providerId="LiveId" clId="{AC88EA9E-70A4-4E13-82F5-A44B617434F3}" dt="2026-04-28T17:22:18.442" v="279" actId="1076"/>
+        <pc:sldMkLst>
+          <pc:docMk/>
+          <pc:sldMk cId="0" sldId="266"/>
+        </pc:sldMkLst>
+        <pc:spChg chg="del">
+          <ac:chgData name="Mi Nguyen" userId="9f5fd27d9273936d" providerId="LiveId" clId="{AC88EA9E-70A4-4E13-82F5-A44B617434F3}" dt="2026-04-28T17:04:01.104" v="234" actId="478"/>
+          <ac:spMkLst>
+            <pc:docMk/>
+            <pc:sldMk cId="0" sldId="266"/>
+            <ac:spMk id="4" creationId="{00000000-0000-0000-0000-000000000000}"/>
+          </ac:spMkLst>
+        </pc:spChg>
+        <pc:spChg chg="del">
+          <ac:chgData name="Mi Nguyen" userId="9f5fd27d9273936d" providerId="LiveId" clId="{AC88EA9E-70A4-4E13-82F5-A44B617434F3}" dt="2026-04-28T17:03:59.184" v="233" actId="478"/>
+          <ac:spMkLst>
+            <pc:docMk/>
+            <pc:sldMk cId="0" sldId="266"/>
+            <ac:spMk id="5" creationId="{00000000-0000-0000-0000-000000000000}"/>
+          </ac:spMkLst>
+        </pc:spChg>
+        <pc:spChg chg="del">
+          <ac:chgData name="Mi Nguyen" userId="9f5fd27d9273936d" providerId="LiveId" clId="{AC88EA9E-70A4-4E13-82F5-A44B617434F3}" dt="2026-04-28T17:05:28.533" v="259" actId="478"/>
+          <ac:spMkLst>
+            <pc:docMk/>
+            <pc:sldMk cId="0" sldId="266"/>
+            <ac:spMk id="6" creationId="{00000000-0000-0000-0000-000000000000}"/>
+          </ac:spMkLst>
+        </pc:spChg>
+        <pc:spChg chg="del mod">
+          <ac:chgData name="Mi Nguyen" userId="9f5fd27d9273936d" providerId="LiveId" clId="{AC88EA9E-70A4-4E13-82F5-A44B617434F3}" dt="2026-04-28T17:05:32.584" v="261" actId="478"/>
+          <ac:spMkLst>
+            <pc:docMk/>
+            <pc:sldMk cId="0" sldId="266"/>
+            <ac:spMk id="7" creationId="{00000000-0000-0000-0000-000000000000}"/>
+          </ac:spMkLst>
+        </pc:spChg>
+        <pc:spChg chg="del">
+          <ac:chgData name="Mi Nguyen" userId="9f5fd27d9273936d" providerId="LiveId" clId="{AC88EA9E-70A4-4E13-82F5-A44B617434F3}" dt="2026-04-28T17:05:22.440" v="256" actId="478"/>
+          <ac:spMkLst>
+            <pc:docMk/>
+            <pc:sldMk cId="0" sldId="266"/>
+            <ac:spMk id="8" creationId="{00000000-0000-0000-0000-000000000000}"/>
+          </ac:spMkLst>
+        </pc:spChg>
+        <pc:spChg chg="del mod">
+          <ac:chgData name="Mi Nguyen" userId="9f5fd27d9273936d" providerId="LiveId" clId="{AC88EA9E-70A4-4E13-82F5-A44B617434F3}" dt="2026-04-28T17:05:20.620" v="255" actId="478"/>
+          <ac:spMkLst>
+            <pc:docMk/>
+            <pc:sldMk cId="0" sldId="266"/>
+            <ac:spMk id="9" creationId="{00000000-0000-0000-0000-000000000000}"/>
+          </ac:spMkLst>
+        </pc:spChg>
+        <pc:spChg chg="del">
+          <ac:chgData name="Mi Nguyen" userId="9f5fd27d9273936d" providerId="LiveId" clId="{AC88EA9E-70A4-4E13-82F5-A44B617434F3}" dt="2026-04-28T17:05:12.688" v="252" actId="478"/>
+          <ac:spMkLst>
+            <pc:docMk/>
+            <pc:sldMk cId="0" sldId="266"/>
+            <ac:spMk id="10" creationId="{00000000-0000-0000-0000-000000000000}"/>
+          </ac:spMkLst>
+        </pc:spChg>
+        <pc:spChg chg="del mod">
+          <ac:chgData name="Mi Nguyen" userId="9f5fd27d9273936d" providerId="LiveId" clId="{AC88EA9E-70A4-4E13-82F5-A44B617434F3}" dt="2026-04-28T17:05:25.346" v="257" actId="478"/>
+          <ac:spMkLst>
+            <pc:docMk/>
+            <pc:sldMk cId="0" sldId="266"/>
+            <ac:spMk id="11" creationId="{00000000-0000-0000-0000-000000000000}"/>
+          </ac:spMkLst>
+        </pc:spChg>
+        <pc:spChg chg="del mod">
+          <ac:chgData name="Mi Nguyen" userId="9f5fd27d9273936d" providerId="LiveId" clId="{AC88EA9E-70A4-4E13-82F5-A44B617434F3}" dt="2026-04-28T17:05:10.884" v="251" actId="478"/>
+          <ac:spMkLst>
+            <pc:docMk/>
+            <pc:sldMk cId="0" sldId="266"/>
+            <ac:spMk id="12" creationId="{00000000-0000-0000-0000-000000000000}"/>
+          </ac:spMkLst>
+        </pc:spChg>
+        <pc:picChg chg="add mod">
+          <ac:chgData name="Mi Nguyen" userId="9f5fd27d9273936d" providerId="LiveId" clId="{AC88EA9E-70A4-4E13-82F5-A44B617434F3}" dt="2026-04-28T17:05:49.814" v="266" actId="1076"/>
+          <ac:picMkLst>
+            <pc:docMk/>
+            <pc:sldMk cId="0" sldId="266"/>
+            <ac:picMk id="14" creationId="{AA2EE0A6-D049-B583-A544-5425A292B36A}"/>
+          </ac:picMkLst>
+        </pc:picChg>
+        <pc:picChg chg="add mod">
+          <ac:chgData name="Mi Nguyen" userId="9f5fd27d9273936d" providerId="LiveId" clId="{AC88EA9E-70A4-4E13-82F5-A44B617434F3}" dt="2026-04-28T17:06:10.101" v="269" actId="1076"/>
+          <ac:picMkLst>
+            <pc:docMk/>
+            <pc:sldMk cId="0" sldId="266"/>
+            <ac:picMk id="16" creationId="{EA7F72D4-D924-926E-D1B6-52CF0BC09423}"/>
+          </ac:picMkLst>
+        </pc:picChg>
+        <pc:picChg chg="add mod">
+          <ac:chgData name="Mi Nguyen" userId="9f5fd27d9273936d" providerId="LiveId" clId="{AC88EA9E-70A4-4E13-82F5-A44B617434F3}" dt="2026-04-28T17:06:20.392" v="271" actId="14100"/>
+          <ac:picMkLst>
+            <pc:docMk/>
+            <pc:sldMk cId="0" sldId="266"/>
+            <ac:picMk id="18" creationId="{2FAD4855-69EA-1F4F-D827-08EA6B69DB00}"/>
+          </ac:picMkLst>
+        </pc:picChg>
+        <pc:picChg chg="add mod">
+          <ac:chgData name="Mi Nguyen" userId="9f5fd27d9273936d" providerId="LiveId" clId="{AC88EA9E-70A4-4E13-82F5-A44B617434F3}" dt="2026-04-28T17:22:18.442" v="279" actId="1076"/>
+          <ac:picMkLst>
+            <pc:docMk/>
+            <pc:sldMk cId="0" sldId="266"/>
+            <ac:picMk id="20" creationId="{F67DAE0E-854B-3C80-7B14-279B77C2E10C}"/>
+          </ac:picMkLst>
+        </pc:picChg>
+      </pc:sldChg>
+      <pc:sldChg chg="modSp mod">
+        <pc:chgData name="Mi Nguyen" userId="9f5fd27d9273936d" providerId="LiveId" clId="{AC88EA9E-70A4-4E13-82F5-A44B617434F3}" dt="2026-04-28T16:20:49.145" v="130" actId="20577"/>
+        <pc:sldMkLst>
+          <pc:docMk/>
+          <pc:sldMk cId="0" sldId="267"/>
+        </pc:sldMkLst>
+        <pc:spChg chg="mod">
+          <ac:chgData name="Mi Nguyen" userId="9f5fd27d9273936d" providerId="LiveId" clId="{AC88EA9E-70A4-4E13-82F5-A44B617434F3}" dt="2026-04-28T16:20:49.145" v="130" actId="20577"/>
+          <ac:spMkLst>
+            <pc:docMk/>
+            <pc:sldMk cId="0" sldId="267"/>
+            <ac:spMk id="4" creationId="{00000000-0000-0000-0000-000000000000}"/>
+          </ac:spMkLst>
+        </pc:spChg>
+      </pc:sldChg>
+      <pc:sldChg chg="addSp delSp modSp add mod ord">
+        <pc:chgData name="Mi Nguyen" userId="9f5fd27d9273936d" providerId="LiveId" clId="{AC88EA9E-70A4-4E13-82F5-A44B617434F3}" dt="2026-04-28T16:57:45.971" v="197"/>
+        <pc:sldMkLst>
+          <pc:docMk/>
+          <pc:sldMk cId="503184617" sldId="268"/>
+        </pc:sldMkLst>
+        <pc:spChg chg="mod">
+          <ac:chgData name="Mi Nguyen" userId="9f5fd27d9273936d" providerId="LiveId" clId="{AC88EA9E-70A4-4E13-82F5-A44B617434F3}" dt="2026-04-28T16:56:31.698" v="174" actId="20577"/>
+          <ac:spMkLst>
+            <pc:docMk/>
+            <pc:sldMk cId="503184617" sldId="268"/>
+            <ac:spMk id="2" creationId="{672EDEA2-43A9-1899-FD81-8DF857C66FC8}"/>
+          </ac:spMkLst>
+        </pc:spChg>
+        <pc:spChg chg="del">
+          <ac:chgData name="Mi Nguyen" userId="9f5fd27d9273936d" providerId="LiveId" clId="{AC88EA9E-70A4-4E13-82F5-A44B617434F3}" dt="2026-04-28T16:56:14.505" v="160" actId="478"/>
+          <ac:spMkLst>
+            <pc:docMk/>
+            <pc:sldMk cId="503184617" sldId="268"/>
+            <ac:spMk id="4" creationId="{30812CDC-01D2-632C-335B-58C8981CC6AD}"/>
+          </ac:spMkLst>
+        </pc:spChg>
+        <pc:spChg chg="del">
+          <ac:chgData name="Mi Nguyen" userId="9f5fd27d9273936d" providerId="LiveId" clId="{AC88EA9E-70A4-4E13-82F5-A44B617434F3}" dt="2026-04-28T16:56:10.617" v="159" actId="478"/>
+          <ac:spMkLst>
+            <pc:docMk/>
+            <pc:sldMk cId="503184617" sldId="268"/>
+            <ac:spMk id="5" creationId="{6C30CF2B-3192-13D0-9A27-D67E6EE3DEF9}"/>
+          </ac:spMkLst>
+        </pc:spChg>
+        <pc:spChg chg="del">
+          <ac:chgData name="Mi Nguyen" userId="9f5fd27d9273936d" providerId="LiveId" clId="{AC88EA9E-70A4-4E13-82F5-A44B617434F3}" dt="2026-04-28T16:56:14.505" v="160" actId="478"/>
+          <ac:spMkLst>
+            <pc:docMk/>
+            <pc:sldMk cId="503184617" sldId="268"/>
+            <ac:spMk id="8" creationId="{1D77D44F-D3F1-86D9-D528-25FB2A3BE14D}"/>
+          </ac:spMkLst>
+        </pc:spChg>
+        <pc:spChg chg="del">
+          <ac:chgData name="Mi Nguyen" userId="9f5fd27d9273936d" providerId="LiveId" clId="{AC88EA9E-70A4-4E13-82F5-A44B617434F3}" dt="2026-04-28T16:56:22.239" v="161" actId="478"/>
+          <ac:spMkLst>
+            <pc:docMk/>
+            <pc:sldMk cId="503184617" sldId="268"/>
+            <ac:spMk id="9" creationId="{2E087A2C-0B8B-CA0F-E3BA-58EAC7D98399}"/>
+          </ac:spMkLst>
+        </pc:spChg>
+        <pc:spChg chg="del">
+          <ac:chgData name="Mi Nguyen" userId="9f5fd27d9273936d" providerId="LiveId" clId="{AC88EA9E-70A4-4E13-82F5-A44B617434F3}" dt="2026-04-28T16:56:22.239" v="161" actId="478"/>
+          <ac:spMkLst>
+            <pc:docMk/>
+            <pc:sldMk cId="503184617" sldId="268"/>
+            <ac:spMk id="10" creationId="{9C97B615-40F7-0C83-1CA5-042C3DB78B94}"/>
+          </ac:spMkLst>
+        </pc:spChg>
+        <pc:spChg chg="del">
+          <ac:chgData name="Mi Nguyen" userId="9f5fd27d9273936d" providerId="LiveId" clId="{AC88EA9E-70A4-4E13-82F5-A44B617434F3}" dt="2026-04-28T16:56:22.239" v="161" actId="478"/>
+          <ac:spMkLst>
+            <pc:docMk/>
+            <pc:sldMk cId="503184617" sldId="268"/>
+            <ac:spMk id="11" creationId="{119EBD4E-73DF-E2CE-3966-39A05B16038F}"/>
+          </ac:spMkLst>
+        </pc:spChg>
+        <pc:spChg chg="del">
+          <ac:chgData name="Mi Nguyen" userId="9f5fd27d9273936d" providerId="LiveId" clId="{AC88EA9E-70A4-4E13-82F5-A44B617434F3}" dt="2026-04-28T16:56:22.239" v="161" actId="478"/>
+          <ac:spMkLst>
+            <pc:docMk/>
+            <pc:sldMk cId="503184617" sldId="268"/>
+            <ac:spMk id="13" creationId="{2428656D-BB2A-6F20-8B82-D986A11BF081}"/>
+          </ac:spMkLst>
+        </pc:spChg>
+        <pc:spChg chg="del">
+          <ac:chgData name="Mi Nguyen" userId="9f5fd27d9273936d" providerId="LiveId" clId="{AC88EA9E-70A4-4E13-82F5-A44B617434F3}" dt="2026-04-28T16:56:14.505" v="160" actId="478"/>
+          <ac:spMkLst>
+            <pc:docMk/>
+            <pc:sldMk cId="503184617" sldId="268"/>
+            <ac:spMk id="14" creationId="{1897E503-8EA0-F580-6BE0-2D2A0FC3D30C}"/>
+          </ac:spMkLst>
+        </pc:spChg>
+        <pc:spChg chg="del">
+          <ac:chgData name="Mi Nguyen" userId="9f5fd27d9273936d" providerId="LiveId" clId="{AC88EA9E-70A4-4E13-82F5-A44B617434F3}" dt="2026-04-28T16:56:14.505" v="160" actId="478"/>
+          <ac:spMkLst>
+            <pc:docMk/>
+            <pc:sldMk cId="503184617" sldId="268"/>
+            <ac:spMk id="17" creationId="{DB82CCCE-D970-F6EC-3BC1-696D35CE2035}"/>
+          </ac:spMkLst>
+        </pc:spChg>
+        <pc:spChg chg="del">
+          <ac:chgData name="Mi Nguyen" userId="9f5fd27d9273936d" providerId="LiveId" clId="{AC88EA9E-70A4-4E13-82F5-A44B617434F3}" dt="2026-04-28T16:56:22.239" v="161" actId="478"/>
+          <ac:spMkLst>
+            <pc:docMk/>
+            <pc:sldMk cId="503184617" sldId="268"/>
+            <ac:spMk id="19" creationId="{DC8C4833-74F0-ADBD-08ED-B9A6E685760C}"/>
+          </ac:spMkLst>
+        </pc:spChg>
+        <pc:spChg chg="del">
+          <ac:chgData name="Mi Nguyen" userId="9f5fd27d9273936d" providerId="LiveId" clId="{AC88EA9E-70A4-4E13-82F5-A44B617434F3}" dt="2026-04-28T16:56:22.239" v="161" actId="478"/>
+          <ac:spMkLst>
+            <pc:docMk/>
+            <pc:sldMk cId="503184617" sldId="268"/>
+            <ac:spMk id="20" creationId="{15A1EEE7-F8A7-D29B-A7E4-BF95CB9ED27A}"/>
+          </ac:spMkLst>
+        </pc:spChg>
+        <pc:spChg chg="del">
+          <ac:chgData name="Mi Nguyen" userId="9f5fd27d9273936d" providerId="LiveId" clId="{AC88EA9E-70A4-4E13-82F5-A44B617434F3}" dt="2026-04-28T16:56:22.239" v="161" actId="478"/>
+          <ac:spMkLst>
+            <pc:docMk/>
+            <pc:sldMk cId="503184617" sldId="268"/>
+            <ac:spMk id="21" creationId="{D9926124-13E3-FDF4-46EA-A3E0CA10A10A}"/>
+          </ac:spMkLst>
+        </pc:spChg>
+        <pc:spChg chg="del">
+          <ac:chgData name="Mi Nguyen" userId="9f5fd27d9273936d" providerId="LiveId" clId="{AC88EA9E-70A4-4E13-82F5-A44B617434F3}" dt="2026-04-28T16:56:22.239" v="161" actId="478"/>
+          <ac:spMkLst>
+            <pc:docMk/>
+            <pc:sldMk cId="503184617" sldId="268"/>
+            <ac:spMk id="23" creationId="{AEE0A5C4-0062-9442-7606-E4A9825117C4}"/>
+          </ac:spMkLst>
+        </pc:spChg>
+        <pc:spChg chg="del">
+          <ac:chgData name="Mi Nguyen" userId="9f5fd27d9273936d" providerId="LiveId" clId="{AC88EA9E-70A4-4E13-82F5-A44B617434F3}" dt="2026-04-28T16:56:14.505" v="160" actId="478"/>
+          <ac:spMkLst>
+            <pc:docMk/>
+            <pc:sldMk cId="503184617" sldId="268"/>
+            <ac:spMk id="24" creationId="{F57B86B3-BED7-2824-87E3-39D3419E6A64}"/>
+          </ac:spMkLst>
+        </pc:spChg>
+        <pc:spChg chg="del">
+          <ac:chgData name="Mi Nguyen" userId="9f5fd27d9273936d" providerId="LiveId" clId="{AC88EA9E-70A4-4E13-82F5-A44B617434F3}" dt="2026-04-28T16:56:14.505" v="160" actId="478"/>
+          <ac:spMkLst>
+            <pc:docMk/>
+            <pc:sldMk cId="503184617" sldId="268"/>
+            <ac:spMk id="26" creationId="{5C323C43-6F2A-68C3-803A-1ED7275F3AB3}"/>
+          </ac:spMkLst>
+        </pc:spChg>
+        <pc:spChg chg="del">
+          <ac:chgData name="Mi Nguyen" userId="9f5fd27d9273936d" providerId="LiveId" clId="{AC88EA9E-70A4-4E13-82F5-A44B617434F3}" dt="2026-04-28T16:56:14.505" v="160" actId="478"/>
+          <ac:spMkLst>
+            <pc:docMk/>
+            <pc:sldMk cId="503184617" sldId="268"/>
+            <ac:spMk id="27" creationId="{1E805C90-BA96-CEAC-E715-A71678730582}"/>
+          </ac:spMkLst>
+        </pc:spChg>
+        <pc:spChg chg="del">
+          <ac:chgData name="Mi Nguyen" userId="9f5fd27d9273936d" providerId="LiveId" clId="{AC88EA9E-70A4-4E13-82F5-A44B617434F3}" dt="2026-04-28T16:56:22.239" v="161" actId="478"/>
+          <ac:spMkLst>
+            <pc:docMk/>
+            <pc:sldMk cId="503184617" sldId="268"/>
+            <ac:spMk id="29" creationId="{41AFF05B-B7DA-19AB-2DA6-7F56ED813D46}"/>
+          </ac:spMkLst>
+        </pc:spChg>
+        <pc:spChg chg="del">
+          <ac:chgData name="Mi Nguyen" userId="9f5fd27d9273936d" providerId="LiveId" clId="{AC88EA9E-70A4-4E13-82F5-A44B617434F3}" dt="2026-04-28T16:56:22.239" v="161" actId="478"/>
+          <ac:spMkLst>
+            <pc:docMk/>
+            <pc:sldMk cId="503184617" sldId="268"/>
+            <ac:spMk id="30" creationId="{869D7079-8884-335F-58FF-49E11ED5DFC8}"/>
+          </ac:spMkLst>
+        </pc:spChg>
+        <pc:spChg chg="del">
+          <ac:chgData name="Mi Nguyen" userId="9f5fd27d9273936d" providerId="LiveId" clId="{AC88EA9E-70A4-4E13-82F5-A44B617434F3}" dt="2026-04-28T16:56:14.505" v="160" actId="478"/>
+          <ac:spMkLst>
+            <pc:docMk/>
+            <pc:sldMk cId="503184617" sldId="268"/>
+            <ac:spMk id="35" creationId="{549A946E-325E-0520-7F91-D81CD8FA3DDF}"/>
+          </ac:spMkLst>
+        </pc:spChg>
+        <pc:spChg chg="del">
+          <ac:chgData name="Mi Nguyen" userId="9f5fd27d9273936d" providerId="LiveId" clId="{AC88EA9E-70A4-4E13-82F5-A44B617434F3}" dt="2026-04-28T16:56:14.505" v="160" actId="478"/>
+          <ac:spMkLst>
+            <pc:docMk/>
+            <pc:sldMk cId="503184617" sldId="268"/>
+            <ac:spMk id="37" creationId="{612A4C76-A332-36C0-14C2-294304FDFB73}"/>
+          </ac:spMkLst>
+        </pc:spChg>
+        <pc:spChg chg="del">
+          <ac:chgData name="Mi Nguyen" userId="9f5fd27d9273936d" providerId="LiveId" clId="{AC88EA9E-70A4-4E13-82F5-A44B617434F3}" dt="2026-04-28T16:56:14.505" v="160" actId="478"/>
+          <ac:spMkLst>
+            <pc:docMk/>
+            <pc:sldMk cId="503184617" sldId="268"/>
+            <ac:spMk id="38" creationId="{A2C221C3-BA38-01BF-1DA8-3123F69883B2}"/>
+          </ac:spMkLst>
+        </pc:spChg>
+        <pc:spChg chg="del">
+          <ac:chgData name="Mi Nguyen" userId="9f5fd27d9273936d" providerId="LiveId" clId="{AC88EA9E-70A4-4E13-82F5-A44B617434F3}" dt="2026-04-28T16:57:04.511" v="180" actId="478"/>
+          <ac:spMkLst>
+            <pc:docMk/>
+            <pc:sldMk cId="503184617" sldId="268"/>
+            <ac:spMk id="39" creationId="{06CFB979-737D-72DB-6D66-DCF0A9FC6714}"/>
+          </ac:spMkLst>
+        </pc:spChg>
+        <pc:spChg chg="add del">
+          <ac:chgData name="Mi Nguyen" userId="9f5fd27d9273936d" providerId="LiveId" clId="{AC88EA9E-70A4-4E13-82F5-A44B617434F3}" dt="2026-04-28T16:56:36.090" v="176" actId="22"/>
+          <ac:spMkLst>
+            <pc:docMk/>
+            <pc:sldMk cId="503184617" sldId="268"/>
+            <ac:spMk id="41" creationId="{F9727F25-5F0F-0222-DACE-4D4FCB1FDCEB}"/>
+          </ac:spMkLst>
+        </pc:spChg>
+        <pc:picChg chg="add mod">
+          <ac:chgData name="Mi Nguyen" userId="9f5fd27d9273936d" providerId="LiveId" clId="{AC88EA9E-70A4-4E13-82F5-A44B617434F3}" dt="2026-04-28T16:57:06.857" v="181" actId="27614"/>
+          <ac:picMkLst>
+            <pc:docMk/>
+            <pc:sldMk cId="503184617" sldId="268"/>
+            <ac:picMk id="43" creationId="{B25B2943-499C-4326-C36E-0C0C1C2180C5}"/>
+          </ac:picMkLst>
+        </pc:picChg>
+      </pc:sldChg>
+      <pc:sldChg chg="new del">
+        <pc:chgData name="Mi Nguyen" userId="9f5fd27d9273936d" providerId="LiveId" clId="{AC88EA9E-70A4-4E13-82F5-A44B617434F3}" dt="2026-04-28T16:54:30.459" v="156" actId="47"/>
+        <pc:sldMkLst>
+          <pc:docMk/>
+          <pc:sldMk cId="1381287338" sldId="268"/>
+        </pc:sldMkLst>
+      </pc:sldChg>
+      <pc:sldChg chg="addSp delSp modSp add mod">
+        <pc:chgData name="Mi Nguyen" userId="9f5fd27d9273936d" providerId="LiveId" clId="{AC88EA9E-70A4-4E13-82F5-A44B617434F3}" dt="2026-04-28T17:02:05.996" v="225" actId="14100"/>
+        <pc:sldMkLst>
+          <pc:docMk/>
+          <pc:sldMk cId="2484762708" sldId="269"/>
+        </pc:sldMkLst>
+        <pc:spChg chg="del">
+          <ac:chgData name="Mi Nguyen" userId="9f5fd27d9273936d" providerId="LiveId" clId="{AC88EA9E-70A4-4E13-82F5-A44B617434F3}" dt="2026-04-28T17:00:44.052" v="212" actId="478"/>
+          <ac:spMkLst>
+            <pc:docMk/>
+            <pc:sldMk cId="2484762708" sldId="269"/>
+            <ac:spMk id="5" creationId="{22DCE946-034E-F79C-B3D4-C3421E6E010A}"/>
+          </ac:spMkLst>
+        </pc:spChg>
+        <pc:spChg chg="del">
+          <ac:chgData name="Mi Nguyen" userId="9f5fd27d9273936d" providerId="LiveId" clId="{AC88EA9E-70A4-4E13-82F5-A44B617434F3}" dt="2026-04-28T17:00:44.052" v="212" actId="478"/>
+          <ac:spMkLst>
+            <pc:docMk/>
+            <pc:sldMk cId="2484762708" sldId="269"/>
+            <ac:spMk id="6" creationId="{33F2D6F1-2040-E74A-120A-FF65BA1B982E}"/>
+          </ac:spMkLst>
+        </pc:spChg>
+        <pc:picChg chg="add mod">
+          <ac:chgData name="Mi Nguyen" userId="9f5fd27d9273936d" providerId="LiveId" clId="{AC88EA9E-70A4-4E13-82F5-A44B617434F3}" dt="2026-04-28T17:01:57.690" v="222" actId="1076"/>
+          <ac:picMkLst>
+            <pc:docMk/>
+            <pc:sldMk cId="2484762708" sldId="269"/>
+            <ac:picMk id="8" creationId="{9E64E538-AA89-28CE-C8D4-6D37DB861C6F}"/>
+          </ac:picMkLst>
+        </pc:picChg>
+        <pc:picChg chg="add mod">
+          <ac:chgData name="Mi Nguyen" userId="9f5fd27d9273936d" providerId="LiveId" clId="{AC88EA9E-70A4-4E13-82F5-A44B617434F3}" dt="2026-04-28T17:02:05.996" v="225" actId="14100"/>
+          <ac:picMkLst>
+            <pc:docMk/>
+            <pc:sldMk cId="2484762708" sldId="269"/>
+            <ac:picMk id="10" creationId="{EB5EF815-9E89-C9B3-24DC-6E3528911770}"/>
+          </ac:picMkLst>
+        </pc:picChg>
+      </pc:sldChg>
+      <pc:sldChg chg="addSp delSp modSp add mod ord">
+        <pc:chgData name="Mi Nguyen" userId="9f5fd27d9273936d" providerId="LiveId" clId="{AC88EA9E-70A4-4E13-82F5-A44B617434F3}" dt="2026-04-28T17:38:25.291" v="353" actId="1076"/>
+        <pc:sldMkLst>
+          <pc:docMk/>
+          <pc:sldMk cId="2160127858" sldId="270"/>
+        </pc:sldMkLst>
+        <pc:spChg chg="mod">
+          <ac:chgData name="Mi Nguyen" userId="9f5fd27d9273936d" providerId="LiveId" clId="{AC88EA9E-70A4-4E13-82F5-A44B617434F3}" dt="2026-04-28T17:35:16.571" v="320" actId="20577"/>
+          <ac:spMkLst>
+            <pc:docMk/>
+            <pc:sldMk cId="2160127858" sldId="270"/>
+            <ac:spMk id="2" creationId="{C453C654-E20C-9E27-2602-4A9F1F744252}"/>
+          </ac:spMkLst>
+        </pc:spChg>
+        <pc:spChg chg="del">
+          <ac:chgData name="Mi Nguyen" userId="9f5fd27d9273936d" providerId="LiveId" clId="{AC88EA9E-70A4-4E13-82F5-A44B617434F3}" dt="2026-04-28T17:35:21.492" v="321" actId="478"/>
+          <ac:spMkLst>
+            <pc:docMk/>
+            <pc:sldMk cId="2160127858" sldId="270"/>
+            <ac:spMk id="4" creationId="{F4EE0BE8-5045-6606-0C8F-DE2021410121}"/>
+          </ac:spMkLst>
+        </pc:spChg>
+        <pc:spChg chg="del">
+          <ac:chgData name="Mi Nguyen" userId="9f5fd27d9273936d" providerId="LiveId" clId="{AC88EA9E-70A4-4E13-82F5-A44B617434F3}" dt="2026-04-28T17:35:23.429" v="322" actId="478"/>
+          <ac:spMkLst>
+            <pc:docMk/>
+            <pc:sldMk cId="2160127858" sldId="270"/>
+            <ac:spMk id="5" creationId="{9B9B1634-D1A5-04E9-A422-0628B966AF07}"/>
+          </ac:spMkLst>
+        </pc:spChg>
+        <pc:spChg chg="del">
+          <ac:chgData name="Mi Nguyen" userId="9f5fd27d9273936d" providerId="LiveId" clId="{AC88EA9E-70A4-4E13-82F5-A44B617434F3}" dt="2026-04-28T17:35:26.688" v="323" actId="478"/>
+          <ac:spMkLst>
+            <pc:docMk/>
+            <pc:sldMk cId="2160127858" sldId="270"/>
+            <ac:spMk id="6" creationId="{04C5B768-07C4-712C-EBE7-C93927CFA0E6}"/>
+          </ac:spMkLst>
+        </pc:spChg>
+        <pc:picChg chg="add mod modCrop">
+          <ac:chgData name="Mi Nguyen" userId="9f5fd27d9273936d" providerId="LiveId" clId="{AC88EA9E-70A4-4E13-82F5-A44B617434F3}" dt="2026-04-28T17:38:25.291" v="353" actId="1076"/>
+          <ac:picMkLst>
+            <pc:docMk/>
+            <pc:sldMk cId="2160127858" sldId="270"/>
+            <ac:picMk id="8" creationId="{63EE4504-E882-55B0-6706-39E7A22B3117}"/>
+          </ac:picMkLst>
+        </pc:picChg>
+        <pc:picChg chg="add del mod">
+          <ac:chgData name="Mi Nguyen" userId="9f5fd27d9273936d" providerId="LiveId" clId="{AC88EA9E-70A4-4E13-82F5-A44B617434F3}" dt="2026-04-28T17:37:15.740" v="341" actId="478"/>
+          <ac:picMkLst>
+            <pc:docMk/>
+            <pc:sldMk cId="2160127858" sldId="270"/>
+            <ac:picMk id="10" creationId="{B5E49D51-1CFD-5353-D08C-C03512F11EB1}"/>
+          </ac:picMkLst>
+        </pc:picChg>
+        <pc:picChg chg="add mod modCrop">
+          <ac:chgData name="Mi Nguyen" userId="9f5fd27d9273936d" providerId="LiveId" clId="{AC88EA9E-70A4-4E13-82F5-A44B617434F3}" dt="2026-04-28T17:38:25.291" v="353" actId="1076"/>
+          <ac:picMkLst>
+            <pc:docMk/>
+            <pc:sldMk cId="2160127858" sldId="270"/>
+            <ac:picMk id="12" creationId="{A19D36D4-73EA-CE0D-23E9-F12C38BB5448}"/>
+          </ac:picMkLst>
+        </pc:picChg>
       </pc:sldChg>
     </pc:docChg>
   </pc:docChgLst>
@@ -552,7 +1149,13 @@
   <p:cSld>
     <p:spTree>
       <p:nvGrpSpPr>
-        <p:cNvPr id="1" name=""/>
+        <p:cNvPr id="1" name="">
+          <a:extLst>
+            <a:ext uri="{FF2B5EF4-FFF2-40B4-BE49-F238E27FC236}">
+              <a16:creationId xmlns:a16="http://schemas.microsoft.com/office/drawing/2014/main" id="{2139892B-C058-14A9-E960-7F3A5960D6EE}"/>
+            </a:ext>
+          </a:extLst>
+        </p:cNvPr>
         <p:cNvGrpSpPr/>
         <p:nvPr/>
       </p:nvGrpSpPr>
@@ -566,7 +1169,13 @@
       </p:grpSpPr>
       <p:sp>
         <p:nvSpPr>
-          <p:cNvPr id="2" name="Slide Image Placeholder 1"/>
+          <p:cNvPr id="2" name="Slide Image Placeholder 1">
+            <a:extLst>
+              <a:ext uri="{FF2B5EF4-FFF2-40B4-BE49-F238E27FC236}">
+                <a16:creationId xmlns:a16="http://schemas.microsoft.com/office/drawing/2014/main" id="{3154A6FF-9C6F-3D5D-8531-390C9600A60E}"/>
+              </a:ext>
+            </a:extLst>
+          </p:cNvPr>
           <p:cNvSpPr>
             <a:spLocks noGrp="1" noRot="1" noChangeAspect="1"/>
           </p:cNvSpPr>
@@ -578,7 +1187,13 @@
       </p:sp>
       <p:sp>
         <p:nvSpPr>
-          <p:cNvPr id="3" name="Notes Placeholder 2"/>
+          <p:cNvPr id="3" name="Notes Placeholder 2">
+            <a:extLst>
+              <a:ext uri="{FF2B5EF4-FFF2-40B4-BE49-F238E27FC236}">
+                <a16:creationId xmlns:a16="http://schemas.microsoft.com/office/drawing/2014/main" id="{5AE4387D-0EC4-8593-C855-C781B1A01287}"/>
+              </a:ext>
+            </a:extLst>
+          </p:cNvPr>
           <p:cNvSpPr>
             <a:spLocks noGrp="1"/>
           </p:cNvSpPr>
@@ -597,7 +1212,13 @@
       </p:sp>
       <p:sp>
         <p:nvSpPr>
-          <p:cNvPr id="4" name="Slide Number Placeholder 3"/>
+          <p:cNvPr id="4" name="Slide Number Placeholder 3">
+            <a:extLst>
+              <a:ext uri="{FF2B5EF4-FFF2-40B4-BE49-F238E27FC236}">
+                <a16:creationId xmlns:a16="http://schemas.microsoft.com/office/drawing/2014/main" id="{DBDF6DA6-14F8-6CF6-9A7E-EDD29F8A03C7}"/>
+              </a:ext>
+            </a:extLst>
+          </p:cNvPr>
           <p:cNvSpPr>
             <a:spLocks noGrp="1"/>
           </p:cNvSpPr>
@@ -621,7 +1242,7 @@
     </p:spTree>
     <p:extLst>
       <p:ext uri="{BB962C8B-B14F-4D97-AF65-F5344CB8AC3E}">
-        <p14:creationId xmlns:p14="http://schemas.microsoft.com/office/powerpoint/2010/main" val="1024086991"/>
+        <p14:creationId xmlns:p14="http://schemas.microsoft.com/office/powerpoint/2010/main" val="3675729839"/>
       </p:ext>
     </p:extLst>
   </p:cSld>
@@ -632,6 +1253,114 @@
 </file>
 
 <file path=ppt/notesSlides/notesSlide12.xml><?xml version="1.0" encoding="utf-8"?>
+<p:notes xmlns:a="http://schemas.openxmlformats.org/drawingml/2006/main" xmlns:r="http://schemas.openxmlformats.org/officeDocument/2006/relationships" xmlns:p="http://schemas.openxmlformats.org/presentationml/2006/main">
+  <p:cSld>
+    <p:spTree>
+      <p:nvGrpSpPr>
+        <p:cNvPr id="1" name="">
+          <a:extLst>
+            <a:ext uri="{FF2B5EF4-FFF2-40B4-BE49-F238E27FC236}">
+              <a16:creationId xmlns:a16="http://schemas.microsoft.com/office/drawing/2014/main" id="{0450B4BA-B4C8-B0B6-DBAD-90AEE437E526}"/>
+            </a:ext>
+          </a:extLst>
+        </p:cNvPr>
+        <p:cNvGrpSpPr/>
+        <p:nvPr/>
+      </p:nvGrpSpPr>
+      <p:grpSpPr>
+        <a:xfrm>
+          <a:off x="0" y="0"/>
+          <a:ext cx="0" cy="0"/>
+          <a:chOff x="0" y="0"/>
+          <a:chExt cx="0" cy="0"/>
+        </a:xfrm>
+      </p:grpSpPr>
+      <p:sp>
+        <p:nvSpPr>
+          <p:cNvPr id="2" name="Slide Image Placeholder 1">
+            <a:extLst>
+              <a:ext uri="{FF2B5EF4-FFF2-40B4-BE49-F238E27FC236}">
+                <a16:creationId xmlns:a16="http://schemas.microsoft.com/office/drawing/2014/main" id="{5D1D3F05-EF28-DE93-A6F7-FE268B0E89F6}"/>
+              </a:ext>
+            </a:extLst>
+          </p:cNvPr>
+          <p:cNvSpPr>
+            <a:spLocks noGrp="1" noRot="1" noChangeAspect="1"/>
+          </p:cNvSpPr>
+          <p:nvPr>
+            <p:ph type="sldImg"/>
+          </p:nvPr>
+        </p:nvSpPr>
+        <p:spPr/>
+      </p:sp>
+      <p:sp>
+        <p:nvSpPr>
+          <p:cNvPr id="3" name="Notes Placeholder 2">
+            <a:extLst>
+              <a:ext uri="{FF2B5EF4-FFF2-40B4-BE49-F238E27FC236}">
+                <a16:creationId xmlns:a16="http://schemas.microsoft.com/office/drawing/2014/main" id="{15574A33-F943-8805-94DB-9130D8B5135B}"/>
+              </a:ext>
+            </a:extLst>
+          </p:cNvPr>
+          <p:cNvSpPr>
+            <a:spLocks noGrp="1"/>
+          </p:cNvSpPr>
+          <p:nvPr>
+            <p:ph type="body" idx="1"/>
+          </p:nvPr>
+        </p:nvSpPr>
+        <p:spPr/>
+        <p:txBody>
+          <a:bodyPr/>
+          <a:lstStyle/>
+          <a:p>
+            <a:endParaRPr lang="en-US" dirty="0"/>
+          </a:p>
+        </p:txBody>
+      </p:sp>
+      <p:sp>
+        <p:nvSpPr>
+          <p:cNvPr id="4" name="Slide Number Placeholder 3">
+            <a:extLst>
+              <a:ext uri="{FF2B5EF4-FFF2-40B4-BE49-F238E27FC236}">
+                <a16:creationId xmlns:a16="http://schemas.microsoft.com/office/drawing/2014/main" id="{4F2B4BC1-AF42-0FBD-F7C1-20C8F72DDF5C}"/>
+              </a:ext>
+            </a:extLst>
+          </p:cNvPr>
+          <p:cNvSpPr>
+            <a:spLocks noGrp="1"/>
+          </p:cNvSpPr>
+          <p:nvPr>
+            <p:ph type="sldNum" sz="quarter" idx="10"/>
+          </p:nvPr>
+        </p:nvSpPr>
+        <p:spPr/>
+        <p:txBody>
+          <a:bodyPr/>
+          <a:lstStyle/>
+          <a:p>
+            <a:fld id="{F7021451-1387-4CA6-816F-3879F97B5CBC}" type="slidenum">
+              <a:rPr lang="en-US"/>
+              <a:t>12</a:t>
+            </a:fld>
+            <a:endParaRPr lang="en-US"/>
+          </a:p>
+        </p:txBody>
+      </p:sp>
+    </p:spTree>
+    <p:extLst>
+      <p:ext uri="{BB962C8B-B14F-4D97-AF65-F5344CB8AC3E}">
+        <p14:creationId xmlns:p14="http://schemas.microsoft.com/office/powerpoint/2010/main" val="1060575382"/>
+      </p:ext>
+    </p:extLst>
+  </p:cSld>
+  <p:clrMapOvr>
+    <a:masterClrMapping/>
+  </p:clrMapOvr>
+</p:notes>
+</file>
+
+<file path=ppt/notesSlides/notesSlide13.xml><?xml version="1.0" encoding="utf-8"?>
 <p:notes xmlns:a="http://schemas.openxmlformats.org/drawingml/2006/main" xmlns:r="http://schemas.openxmlformats.org/officeDocument/2006/relationships" xmlns:p="http://schemas.openxmlformats.org/presentationml/2006/main">
   <p:cSld>
     <p:spTree>
@@ -696,7 +1425,175 @@
           <a:p>
             <a:fld id="{F7021451-1387-4CA6-816F-3879F97B5CBC}" type="slidenum">
               <a:rPr lang="en-US"/>
-              <a:t>12</a:t>
+              <a:t>13</a:t>
+            </a:fld>
+            <a:endParaRPr lang="en-US"/>
+          </a:p>
+        </p:txBody>
+      </p:sp>
+    </p:spTree>
+    <p:extLst>
+      <p:ext uri="{BB962C8B-B14F-4D97-AF65-F5344CB8AC3E}">
+        <p14:creationId xmlns:p14="http://schemas.microsoft.com/office/powerpoint/2010/main" val="1024086991"/>
+      </p:ext>
+    </p:extLst>
+  </p:cSld>
+  <p:clrMapOvr>
+    <a:masterClrMapping/>
+  </p:clrMapOvr>
+</p:notes>
+</file>
+
+<file path=ppt/notesSlides/notesSlide14.xml><?xml version="1.0" encoding="utf-8"?>
+<p:notes xmlns:a="http://schemas.openxmlformats.org/drawingml/2006/main" xmlns:r="http://schemas.openxmlformats.org/officeDocument/2006/relationships" xmlns:p="http://schemas.openxmlformats.org/presentationml/2006/main">
+  <p:cSld>
+    <p:spTree>
+      <p:nvGrpSpPr>
+        <p:cNvPr id="1" name=""/>
+        <p:cNvGrpSpPr/>
+        <p:nvPr/>
+      </p:nvGrpSpPr>
+      <p:grpSpPr>
+        <a:xfrm>
+          <a:off x="0" y="0"/>
+          <a:ext cx="0" cy="0"/>
+          <a:chOff x="0" y="0"/>
+          <a:chExt cx="0" cy="0"/>
+        </a:xfrm>
+      </p:grpSpPr>
+      <p:sp>
+        <p:nvSpPr>
+          <p:cNvPr id="2" name="Slide Image Placeholder 1"/>
+          <p:cNvSpPr>
+            <a:spLocks noGrp="1" noRot="1" noChangeAspect="1"/>
+          </p:cNvSpPr>
+          <p:nvPr>
+            <p:ph type="sldImg"/>
+          </p:nvPr>
+        </p:nvSpPr>
+        <p:spPr/>
+      </p:sp>
+      <p:sp>
+        <p:nvSpPr>
+          <p:cNvPr id="3" name="Notes Placeholder 2"/>
+          <p:cNvSpPr>
+            <a:spLocks noGrp="1"/>
+          </p:cNvSpPr>
+          <p:nvPr>
+            <p:ph type="body" idx="1"/>
+          </p:nvPr>
+        </p:nvSpPr>
+        <p:spPr/>
+        <p:txBody>
+          <a:bodyPr/>
+          <a:lstStyle/>
+          <a:p>
+            <a:endParaRPr lang="en-US" dirty="0"/>
+          </a:p>
+        </p:txBody>
+      </p:sp>
+      <p:sp>
+        <p:nvSpPr>
+          <p:cNvPr id="4" name="Slide Number Placeholder 3"/>
+          <p:cNvSpPr>
+            <a:spLocks noGrp="1"/>
+          </p:cNvSpPr>
+          <p:nvPr>
+            <p:ph type="sldNum" sz="quarter" idx="10"/>
+          </p:nvPr>
+        </p:nvSpPr>
+        <p:spPr/>
+        <p:txBody>
+          <a:bodyPr/>
+          <a:lstStyle/>
+          <a:p>
+            <a:fld id="{F7021451-1387-4CA6-816F-3879F97B5CBC}" type="slidenum">
+              <a:rPr lang="en-US"/>
+              <a:t>14</a:t>
+            </a:fld>
+            <a:endParaRPr lang="en-US"/>
+          </a:p>
+        </p:txBody>
+      </p:sp>
+    </p:spTree>
+    <p:extLst>
+      <p:ext uri="{BB962C8B-B14F-4D97-AF65-F5344CB8AC3E}">
+        <p14:creationId xmlns:p14="http://schemas.microsoft.com/office/powerpoint/2010/main" val="1024086991"/>
+      </p:ext>
+    </p:extLst>
+  </p:cSld>
+  <p:clrMapOvr>
+    <a:masterClrMapping/>
+  </p:clrMapOvr>
+</p:notes>
+</file>
+
+<file path=ppt/notesSlides/notesSlide15.xml><?xml version="1.0" encoding="utf-8"?>
+<p:notes xmlns:a="http://schemas.openxmlformats.org/drawingml/2006/main" xmlns:r="http://schemas.openxmlformats.org/officeDocument/2006/relationships" xmlns:p="http://schemas.openxmlformats.org/presentationml/2006/main">
+  <p:cSld>
+    <p:spTree>
+      <p:nvGrpSpPr>
+        <p:cNvPr id="1" name=""/>
+        <p:cNvGrpSpPr/>
+        <p:nvPr/>
+      </p:nvGrpSpPr>
+      <p:grpSpPr>
+        <a:xfrm>
+          <a:off x="0" y="0"/>
+          <a:ext cx="0" cy="0"/>
+          <a:chOff x="0" y="0"/>
+          <a:chExt cx="0" cy="0"/>
+        </a:xfrm>
+      </p:grpSpPr>
+      <p:sp>
+        <p:nvSpPr>
+          <p:cNvPr id="2" name="Slide Image Placeholder 1"/>
+          <p:cNvSpPr>
+            <a:spLocks noGrp="1" noRot="1" noChangeAspect="1"/>
+          </p:cNvSpPr>
+          <p:nvPr>
+            <p:ph type="sldImg"/>
+          </p:nvPr>
+        </p:nvSpPr>
+        <p:spPr/>
+      </p:sp>
+      <p:sp>
+        <p:nvSpPr>
+          <p:cNvPr id="3" name="Notes Placeholder 2"/>
+          <p:cNvSpPr>
+            <a:spLocks noGrp="1"/>
+          </p:cNvSpPr>
+          <p:nvPr>
+            <p:ph type="body" idx="1"/>
+          </p:nvPr>
+        </p:nvSpPr>
+        <p:spPr/>
+        <p:txBody>
+          <a:bodyPr/>
+          <a:lstStyle/>
+          <a:p>
+            <a:endParaRPr lang="en-US" dirty="0"/>
+          </a:p>
+        </p:txBody>
+      </p:sp>
+      <p:sp>
+        <p:nvSpPr>
+          <p:cNvPr id="4" name="Slide Number Placeholder 3"/>
+          <p:cNvSpPr>
+            <a:spLocks noGrp="1"/>
+          </p:cNvSpPr>
+          <p:nvPr>
+            <p:ph type="sldNum" sz="quarter" idx="10"/>
+          </p:nvPr>
+        </p:nvSpPr>
+        <p:spPr/>
+        <p:txBody>
+          <a:bodyPr/>
+          <a:lstStyle/>
+          <a:p>
+            <a:fld id="{F7021451-1387-4CA6-816F-3879F97B5CBC}" type="slidenum">
+              <a:rPr lang="en-US"/>
+              <a:t>15</a:t>
             </a:fld>
             <a:endParaRPr lang="en-US"/>
           </a:p>
@@ -972,7 +1869,13 @@
   <p:cSld>
     <p:spTree>
       <p:nvGrpSpPr>
-        <p:cNvPr id="1" name=""/>
+        <p:cNvPr id="1" name="">
+          <a:extLst>
+            <a:ext uri="{FF2B5EF4-FFF2-40B4-BE49-F238E27FC236}">
+              <a16:creationId xmlns:a16="http://schemas.microsoft.com/office/drawing/2014/main" id="{BC2E8EEE-4D5F-3066-8941-B5CEEDA9AE90}"/>
+            </a:ext>
+          </a:extLst>
+        </p:cNvPr>
         <p:cNvGrpSpPr/>
         <p:nvPr/>
       </p:nvGrpSpPr>
@@ -986,7 +1889,13 @@
       </p:grpSpPr>
       <p:sp>
         <p:nvSpPr>
-          <p:cNvPr id="2" name="Slide Image Placeholder 1"/>
+          <p:cNvPr id="2" name="Slide Image Placeholder 1">
+            <a:extLst>
+              <a:ext uri="{FF2B5EF4-FFF2-40B4-BE49-F238E27FC236}">
+                <a16:creationId xmlns:a16="http://schemas.microsoft.com/office/drawing/2014/main" id="{5ABF9367-9D3B-9BD4-A879-532FCE4CF4C9}"/>
+              </a:ext>
+            </a:extLst>
+          </p:cNvPr>
           <p:cNvSpPr>
             <a:spLocks noGrp="1" noRot="1" noChangeAspect="1"/>
           </p:cNvSpPr>
@@ -998,7 +1907,13 @@
       </p:sp>
       <p:sp>
         <p:nvSpPr>
-          <p:cNvPr id="3" name="Notes Placeholder 2"/>
+          <p:cNvPr id="3" name="Notes Placeholder 2">
+            <a:extLst>
+              <a:ext uri="{FF2B5EF4-FFF2-40B4-BE49-F238E27FC236}">
+                <a16:creationId xmlns:a16="http://schemas.microsoft.com/office/drawing/2014/main" id="{0EEDEF0B-6E89-5E9A-94D2-082729A40B84}"/>
+              </a:ext>
+            </a:extLst>
+          </p:cNvPr>
           <p:cNvSpPr>
             <a:spLocks noGrp="1"/>
           </p:cNvSpPr>
@@ -1017,7 +1932,13 @@
       </p:sp>
       <p:sp>
         <p:nvSpPr>
-          <p:cNvPr id="4" name="Slide Number Placeholder 3"/>
+          <p:cNvPr id="4" name="Slide Number Placeholder 3">
+            <a:extLst>
+              <a:ext uri="{FF2B5EF4-FFF2-40B4-BE49-F238E27FC236}">
+                <a16:creationId xmlns:a16="http://schemas.microsoft.com/office/drawing/2014/main" id="{A9250AEE-5CA3-72E5-7123-9203E92FCFD7}"/>
+              </a:ext>
+            </a:extLst>
+          </p:cNvPr>
           <p:cNvSpPr>
             <a:spLocks noGrp="1"/>
           </p:cNvSpPr>
@@ -1041,7 +1962,7 @@
     </p:spTree>
     <p:extLst>
       <p:ext uri="{BB962C8B-B14F-4D97-AF65-F5344CB8AC3E}">
-        <p14:creationId xmlns:p14="http://schemas.microsoft.com/office/powerpoint/2010/main" val="1024086991"/>
+        <p14:creationId xmlns:p14="http://schemas.microsoft.com/office/powerpoint/2010/main" val="3945993838"/>
       </p:ext>
     </p:extLst>
   </p:cSld>
@@ -2056,27 +2977,6 @@
                 <a:ea typeface="Calibri" pitchFamily="34" charset="-122"/>
                 <a:cs typeface="Calibri" pitchFamily="34" charset="-120"/>
               </a:rPr>
-              <a:t>backend/src/dtos/schemas.test.ts — Zod DTO validation (valid/invalid payloads for all schemas)</a:t>
-            </a:r>
-            <a:endParaRPr lang="en-US" sz="1500" dirty="0"/>
-          </a:p>
-          <a:p>
-            <a:pPr marL="342900" indent="-342900">
-              <a:spcAft>
-                <a:spcPts val="600"/>
-              </a:spcAft>
-              <a:buSzPct val="100000"/>
-              <a:buChar char="•"/>
-            </a:pPr>
-            <a:r>
-              <a:rPr lang="en-US" sz="1500" dirty="0">
-                <a:solidFill>
-                  <a:srgbClr val="E8EAF0"/>
-                </a:solidFill>
-                <a:latin typeface="Calibri" pitchFamily="34" charset="0"/>
-                <a:ea typeface="Calibri" pitchFamily="34" charset="-122"/>
-                <a:cs typeface="Calibri" pitchFamily="34" charset="-120"/>
-              </a:rPr>
               <a:t>backend/src/database/schema.prisma.test.ts — Prisma schema structure validation</a:t>
             </a:r>
             <a:endParaRPr lang="en-US" sz="1500" dirty="0"/>
@@ -2226,6 +3126,887 @@
 </file>
 
 <file path=ppt/slides/slide11.xml><?xml version="1.0" encoding="utf-8"?>
+<p:sld xmlns:a="http://schemas.openxmlformats.org/drawingml/2006/main" xmlns:r="http://schemas.openxmlformats.org/officeDocument/2006/relationships" xmlns:p="http://schemas.openxmlformats.org/presentationml/2006/main">
+  <p:cSld>
+    <p:bg>
+      <p:bgPr>
+        <a:solidFill>
+          <a:srgbClr val="0F1624"/>
+        </a:solidFill>
+        <a:effectLst/>
+      </p:bgPr>
+    </p:bg>
+    <p:spTree>
+      <p:nvGrpSpPr>
+        <p:cNvPr id="1" name="">
+          <a:extLst>
+            <a:ext uri="{FF2B5EF4-FFF2-40B4-BE49-F238E27FC236}">
+              <a16:creationId xmlns:a16="http://schemas.microsoft.com/office/drawing/2014/main" id="{E5114D6C-6358-186B-2950-716C9F259A01}"/>
+            </a:ext>
+          </a:extLst>
+        </p:cNvPr>
+        <p:cNvGrpSpPr/>
+        <p:nvPr/>
+      </p:nvGrpSpPr>
+      <p:grpSpPr>
+        <a:xfrm>
+          <a:off x="0" y="0"/>
+          <a:ext cx="0" cy="0"/>
+          <a:chOff x="0" y="0"/>
+          <a:chExt cx="0" cy="0"/>
+        </a:xfrm>
+      </p:grpSpPr>
+      <p:sp>
+        <p:nvSpPr>
+          <p:cNvPr id="2" name="Text 0">
+            <a:extLst>
+              <a:ext uri="{FF2B5EF4-FFF2-40B4-BE49-F238E27FC236}">
+                <a16:creationId xmlns:a16="http://schemas.microsoft.com/office/drawing/2014/main" id="{74BD91CC-D4D3-5B92-CC4F-DEB8AF2B093E}"/>
+              </a:ext>
+            </a:extLst>
+          </p:cNvPr>
+          <p:cNvSpPr/>
+          <p:nvPr/>
+        </p:nvSpPr>
+        <p:spPr>
+          <a:xfrm>
+            <a:off x="457200" y="256032"/>
+            <a:ext cx="8229600" cy="594360"/>
+          </a:xfrm>
+          <a:prstGeom prst="rect">
+            <a:avLst/>
+          </a:prstGeom>
+          <a:noFill/>
+          <a:ln/>
+        </p:spPr>
+        <p:txBody>
+          <a:bodyPr wrap="square" lIns="0" tIns="0" rIns="0" bIns="0" rtlCol="0" anchor="ctr"/>
+          <a:lstStyle/>
+          <a:p>
+            <a:pPr marL="0" indent="0" algn="l">
+              <a:buNone/>
+            </a:pPr>
+            <a:r>
+              <a:rPr lang="en-US" sz="3200" b="1" dirty="0">
+                <a:solidFill>
+                  <a:srgbClr val="FFFFFF"/>
+                </a:solidFill>
+                <a:latin typeface="Calibri" pitchFamily="34" charset="0"/>
+                <a:ea typeface="Calibri" pitchFamily="34" charset="-122"/>
+                <a:cs typeface="Calibri" pitchFamily="34" charset="-120"/>
+              </a:rPr>
+              <a:t>Unit Test Coverage</a:t>
+            </a:r>
+            <a:endParaRPr lang="en-US" sz="3200" dirty="0"/>
+          </a:p>
+        </p:txBody>
+      </p:sp>
+      <p:sp>
+        <p:nvSpPr>
+          <p:cNvPr id="3" name="Shape 1">
+            <a:extLst>
+              <a:ext uri="{FF2B5EF4-FFF2-40B4-BE49-F238E27FC236}">
+                <a16:creationId xmlns:a16="http://schemas.microsoft.com/office/drawing/2014/main" id="{1C57C2B7-3945-B0A7-57AE-FC7368B9193B}"/>
+              </a:ext>
+            </a:extLst>
+          </p:cNvPr>
+          <p:cNvSpPr/>
+          <p:nvPr/>
+        </p:nvSpPr>
+        <p:spPr>
+          <a:xfrm>
+            <a:off x="457200" y="877824"/>
+            <a:ext cx="8229600" cy="22860"/>
+          </a:xfrm>
+          <a:prstGeom prst="rect">
+            <a:avLst/>
+          </a:prstGeom>
+          <a:solidFill>
+            <a:srgbClr val="E94560"/>
+          </a:solidFill>
+          <a:ln w="12700">
+            <a:solidFill>
+              <a:srgbClr val="E94560"/>
+            </a:solidFill>
+            <a:prstDash val="solid"/>
+          </a:ln>
+        </p:spPr>
+        <p:txBody>
+          <a:bodyPr/>
+          <a:lstStyle/>
+          <a:p>
+            <a:endParaRPr lang="en-US"/>
+          </a:p>
+        </p:txBody>
+      </p:sp>
+      <p:sp>
+        <p:nvSpPr>
+          <p:cNvPr id="4" name="Text 2">
+            <a:extLst>
+              <a:ext uri="{FF2B5EF4-FFF2-40B4-BE49-F238E27FC236}">
+                <a16:creationId xmlns:a16="http://schemas.microsoft.com/office/drawing/2014/main" id="{B9C8B0D0-7095-7F64-17F3-31CB95E56FF4}"/>
+              </a:ext>
+            </a:extLst>
+          </p:cNvPr>
+          <p:cNvSpPr/>
+          <p:nvPr/>
+        </p:nvSpPr>
+        <p:spPr>
+          <a:xfrm>
+            <a:off x="502920" y="1051560"/>
+            <a:ext cx="8138160" cy="3474720"/>
+          </a:xfrm>
+          <a:prstGeom prst="rect">
+            <a:avLst/>
+          </a:prstGeom>
+          <a:noFill/>
+          <a:ln/>
+        </p:spPr>
+        <p:txBody>
+          <a:bodyPr wrap="square" rtlCol="0" anchor="t"/>
+          <a:lstStyle/>
+          <a:p>
+            <a:pPr marL="342900" indent="-342900">
+              <a:spcAft>
+                <a:spcPts val="600"/>
+              </a:spcAft>
+              <a:buSzPct val="100000"/>
+              <a:buChar char="•"/>
+            </a:pPr>
+            <a:r>
+              <a:rPr lang="en-US" sz="1500" dirty="0">
+                <a:solidFill>
+                  <a:srgbClr val="E8EAF0"/>
+                </a:solidFill>
+                <a:latin typeface="Calibri" pitchFamily="34" charset="0"/>
+                <a:ea typeface="Calibri" pitchFamily="34" charset="-122"/>
+                <a:cs typeface="Calibri" pitchFamily="34" charset="-120"/>
+              </a:rPr>
+              <a:t>Framework: Vitest (both frontend and backend packages)</a:t>
+            </a:r>
+            <a:endParaRPr lang="en-US" sz="1500" dirty="0"/>
+          </a:p>
+          <a:p>
+            <a:pPr marL="342900" indent="-342900">
+              <a:spcAft>
+                <a:spcPts val="600"/>
+              </a:spcAft>
+              <a:buSzPct val="100000"/>
+              <a:buChar char="•"/>
+            </a:pPr>
+            <a:r>
+              <a:rPr lang="en-US" sz="1500" dirty="0">
+                <a:solidFill>
+                  <a:srgbClr val="E8EAF0"/>
+                </a:solidFill>
+                <a:latin typeface="Calibri" pitchFamily="34" charset="0"/>
+                <a:ea typeface="Calibri" pitchFamily="34" charset="-122"/>
+                <a:cs typeface="Calibri" pitchFamily="34" charset="-120"/>
+              </a:rPr>
+              <a:t>backend/src/utils/jwt.test.ts — sign/verify access and refresh tokens</a:t>
+            </a:r>
+            <a:endParaRPr lang="en-US" sz="1500" dirty="0"/>
+          </a:p>
+          <a:p>
+            <a:pPr marL="342900" indent="-342900">
+              <a:spcAft>
+                <a:spcPts val="600"/>
+              </a:spcAft>
+              <a:buSzPct val="100000"/>
+              <a:buChar char="•"/>
+            </a:pPr>
+            <a:r>
+              <a:rPr lang="en-US" sz="1500" dirty="0">
+                <a:solidFill>
+                  <a:srgbClr val="E8EAF0"/>
+                </a:solidFill>
+                <a:latin typeface="Calibri" pitchFamily="34" charset="0"/>
+                <a:ea typeface="Calibri" pitchFamily="34" charset="-122"/>
+                <a:cs typeface="Calibri" pitchFamily="34" charset="-120"/>
+              </a:rPr>
+              <a:t>backend/src/database/schema.prisma.test.ts — Prisma schema structure validation</a:t>
+            </a:r>
+            <a:endParaRPr lang="en-US" sz="1500" dirty="0"/>
+          </a:p>
+          <a:p>
+            <a:pPr marL="342900" indent="-342900">
+              <a:spcAft>
+                <a:spcPts val="600"/>
+              </a:spcAft>
+              <a:buSzPct val="100000"/>
+              <a:buChar char="•"/>
+            </a:pPr>
+            <a:r>
+              <a:rPr lang="en-US" sz="1500" dirty="0">
+                <a:solidFill>
+                  <a:srgbClr val="E8EAF0"/>
+                </a:solidFill>
+                <a:latin typeface="Calibri" pitchFamily="34" charset="0"/>
+                <a:ea typeface="Calibri" pitchFamily="34" charset="-122"/>
+                <a:cs typeface="Calibri" pitchFamily="34" charset="-120"/>
+              </a:rPr>
+              <a:t>frontend/src/App.test.jsx — top-level app render and route guards</a:t>
+            </a:r>
+            <a:endParaRPr lang="en-US" sz="1500" dirty="0"/>
+          </a:p>
+          <a:p>
+            <a:pPr marL="342900" indent="-342900">
+              <a:spcAft>
+                <a:spcPts val="600"/>
+              </a:spcAft>
+              <a:buSzPct val="100000"/>
+              <a:buChar char="•"/>
+            </a:pPr>
+            <a:r>
+              <a:rPr lang="en-US" sz="1500" dirty="0">
+                <a:solidFill>
+                  <a:srgbClr val="E8EAF0"/>
+                </a:solidFill>
+                <a:latin typeface="Calibri" pitchFamily="34" charset="0"/>
+                <a:ea typeface="Calibri" pitchFamily="34" charset="-122"/>
+                <a:cs typeface="Calibri" pitchFamily="34" charset="-120"/>
+              </a:rPr>
+              <a:t>frontend/src/HomePage.test.jsx — home page component rendering</a:t>
+            </a:r>
+            <a:endParaRPr lang="en-US" sz="1500" dirty="0"/>
+          </a:p>
+          <a:p>
+            <a:pPr marL="342900" indent="-342900">
+              <a:spcAft>
+                <a:spcPts val="600"/>
+              </a:spcAft>
+              <a:buSzPct val="100000"/>
+              <a:buChar char="•"/>
+            </a:pPr>
+            <a:r>
+              <a:rPr lang="en-US" sz="1500" dirty="0">
+                <a:solidFill>
+                  <a:srgbClr val="E8EAF0"/>
+                </a:solidFill>
+                <a:latin typeface="Calibri" pitchFamily="34" charset="0"/>
+                <a:ea typeface="Calibri" pitchFamily="34" charset="-122"/>
+                <a:cs typeface="Calibri" pitchFamily="34" charset="-120"/>
+              </a:rPr>
+              <a:t>frontend/src/GroupPage.test.jsx — group listing and navigation</a:t>
+            </a:r>
+            <a:endParaRPr lang="en-US" sz="1500" dirty="0"/>
+          </a:p>
+        </p:txBody>
+      </p:sp>
+      <p:pic>
+        <p:nvPicPr>
+          <p:cNvPr id="8" name="Picture 7" descr="The image displays a terminal output from a testing session, indicating successful execution of tests for a backend application, including database schema, data transfer objects, and JWT validations.&#10;&#10;AI-generated content may be incorrect.">
+            <a:extLst>
+              <a:ext uri="{FF2B5EF4-FFF2-40B4-BE49-F238E27FC236}">
+                <a16:creationId xmlns:a16="http://schemas.microsoft.com/office/drawing/2014/main" id="{9E64E538-AA89-28CE-C8D4-6D37DB861C6F}"/>
+              </a:ext>
+            </a:extLst>
+          </p:cNvPr>
+          <p:cNvPicPr>
+            <a:picLocks noChangeAspect="1"/>
+          </p:cNvPicPr>
+          <p:nvPr/>
+        </p:nvPicPr>
+        <p:blipFill>
+          <a:blip r:embed="rId3"/>
+          <a:stretch>
+            <a:fillRect/>
+          </a:stretch>
+        </p:blipFill>
+        <p:spPr>
+          <a:xfrm>
+            <a:off x="4529612" y="3164067"/>
+            <a:ext cx="4400172" cy="1723401"/>
+          </a:xfrm>
+          <a:prstGeom prst="rect">
+            <a:avLst/>
+          </a:prstGeom>
+        </p:spPr>
+      </p:pic>
+      <p:pic>
+        <p:nvPicPr>
+          <p:cNvPr id="10" name="Picture 9">
+            <a:extLst>
+              <a:ext uri="{FF2B5EF4-FFF2-40B4-BE49-F238E27FC236}">
+                <a16:creationId xmlns:a16="http://schemas.microsoft.com/office/drawing/2014/main" id="{EB5EF815-9E89-C9B3-24DC-6E3528911770}"/>
+              </a:ext>
+            </a:extLst>
+          </p:cNvPr>
+          <p:cNvPicPr>
+            <a:picLocks noChangeAspect="1"/>
+          </p:cNvPicPr>
+          <p:nvPr/>
+        </p:nvPicPr>
+        <p:blipFill>
+          <a:blip r:embed="rId4"/>
+          <a:stretch>
+            <a:fillRect/>
+          </a:stretch>
+        </p:blipFill>
+        <p:spPr>
+          <a:xfrm>
+            <a:off x="139280" y="3207404"/>
+            <a:ext cx="4226829" cy="1636725"/>
+          </a:xfrm>
+          <a:prstGeom prst="rect">
+            <a:avLst/>
+          </a:prstGeom>
+        </p:spPr>
+      </p:pic>
+    </p:spTree>
+    <p:extLst>
+      <p:ext uri="{BB962C8B-B14F-4D97-AF65-F5344CB8AC3E}">
+        <p14:creationId xmlns:p14="http://schemas.microsoft.com/office/powerpoint/2010/main" val="2484762708"/>
+      </p:ext>
+    </p:extLst>
+  </p:cSld>
+  <p:clrMapOvr>
+    <a:masterClrMapping/>
+  </p:clrMapOvr>
+</p:sld>
+</file>
+
+<file path=ppt/slides/slide12.xml><?xml version="1.0" encoding="utf-8"?>
+<p:sld xmlns:a="http://schemas.openxmlformats.org/drawingml/2006/main" xmlns:r="http://schemas.openxmlformats.org/officeDocument/2006/relationships" xmlns:p="http://schemas.openxmlformats.org/presentationml/2006/main">
+  <p:cSld>
+    <p:bg>
+      <p:bgPr>
+        <a:solidFill>
+          <a:srgbClr val="0F1624"/>
+        </a:solidFill>
+        <a:effectLst/>
+      </p:bgPr>
+    </p:bg>
+    <p:spTree>
+      <p:nvGrpSpPr>
+        <p:cNvPr id="1" name="">
+          <a:extLst>
+            <a:ext uri="{FF2B5EF4-FFF2-40B4-BE49-F238E27FC236}">
+              <a16:creationId xmlns:a16="http://schemas.microsoft.com/office/drawing/2014/main" id="{4AD2FA53-B78A-8535-469C-29D9CA4875DE}"/>
+            </a:ext>
+          </a:extLst>
+        </p:cNvPr>
+        <p:cNvGrpSpPr/>
+        <p:nvPr/>
+      </p:nvGrpSpPr>
+      <p:grpSpPr>
+        <a:xfrm>
+          <a:off x="0" y="0"/>
+          <a:ext cx="0" cy="0"/>
+          <a:chOff x="0" y="0"/>
+          <a:chExt cx="0" cy="0"/>
+        </a:xfrm>
+      </p:grpSpPr>
+      <p:sp>
+        <p:nvSpPr>
+          <p:cNvPr id="2" name="Text 0">
+            <a:extLst>
+              <a:ext uri="{FF2B5EF4-FFF2-40B4-BE49-F238E27FC236}">
+                <a16:creationId xmlns:a16="http://schemas.microsoft.com/office/drawing/2014/main" id="{C453C654-E20C-9E27-2602-4A9F1F744252}"/>
+              </a:ext>
+            </a:extLst>
+          </p:cNvPr>
+          <p:cNvSpPr/>
+          <p:nvPr/>
+        </p:nvSpPr>
+        <p:spPr>
+          <a:xfrm>
+            <a:off x="457200" y="256032"/>
+            <a:ext cx="8229600" cy="594360"/>
+          </a:xfrm>
+          <a:prstGeom prst="rect">
+            <a:avLst/>
+          </a:prstGeom>
+          <a:noFill/>
+          <a:ln/>
+        </p:spPr>
+        <p:txBody>
+          <a:bodyPr wrap="square" lIns="0" tIns="0" rIns="0" bIns="0" rtlCol="0" anchor="ctr"/>
+          <a:lstStyle/>
+          <a:p>
+            <a:pPr marL="0" indent="0" algn="l">
+              <a:buNone/>
+            </a:pPr>
+            <a:r>
+              <a:rPr lang="en-US" sz="3200" b="1" dirty="0">
+                <a:solidFill>
+                  <a:srgbClr val="FFFFFF"/>
+                </a:solidFill>
+                <a:latin typeface="Calibri" pitchFamily="34" charset="0"/>
+                <a:ea typeface="Calibri" pitchFamily="34" charset="-122"/>
+                <a:cs typeface="Calibri" pitchFamily="34" charset="-120"/>
+              </a:rPr>
+              <a:t>Prompts</a:t>
+            </a:r>
+            <a:endParaRPr lang="en-US" sz="3200" dirty="0"/>
+          </a:p>
+        </p:txBody>
+      </p:sp>
+      <p:sp>
+        <p:nvSpPr>
+          <p:cNvPr id="3" name="Shape 1">
+            <a:extLst>
+              <a:ext uri="{FF2B5EF4-FFF2-40B4-BE49-F238E27FC236}">
+                <a16:creationId xmlns:a16="http://schemas.microsoft.com/office/drawing/2014/main" id="{71118F93-9EFA-D898-3828-4DD1BB3A6857}"/>
+              </a:ext>
+            </a:extLst>
+          </p:cNvPr>
+          <p:cNvSpPr/>
+          <p:nvPr/>
+        </p:nvSpPr>
+        <p:spPr>
+          <a:xfrm>
+            <a:off x="457200" y="877824"/>
+            <a:ext cx="8229600" cy="22860"/>
+          </a:xfrm>
+          <a:prstGeom prst="rect">
+            <a:avLst/>
+          </a:prstGeom>
+          <a:solidFill>
+            <a:srgbClr val="E94560"/>
+          </a:solidFill>
+          <a:ln w="12700">
+            <a:solidFill>
+              <a:srgbClr val="E94560"/>
+            </a:solidFill>
+            <a:prstDash val="solid"/>
+          </a:ln>
+        </p:spPr>
+        <p:txBody>
+          <a:bodyPr/>
+          <a:lstStyle/>
+          <a:p>
+            <a:endParaRPr lang="en-US"/>
+          </a:p>
+        </p:txBody>
+      </p:sp>
+      <p:pic>
+        <p:nvPicPr>
+          <p:cNvPr id="8" name="Picture 7" descr="The image displays a webpage with a code editor interface, containing a file listing and code snippets related to a software engineering project.&#10;&#10;AI-generated content may be incorrect.">
+            <a:extLst>
+              <a:ext uri="{FF2B5EF4-FFF2-40B4-BE49-F238E27FC236}">
+                <a16:creationId xmlns:a16="http://schemas.microsoft.com/office/drawing/2014/main" id="{63EE4504-E882-55B0-6706-39E7A22B3117}"/>
+              </a:ext>
+            </a:extLst>
+          </p:cNvPr>
+          <p:cNvPicPr>
+            <a:picLocks noChangeAspect="1"/>
+          </p:cNvPicPr>
+          <p:nvPr/>
+        </p:nvPicPr>
+        <p:blipFill>
+          <a:blip r:embed="rId3"/>
+          <a:srcRect l="25996" t="36991" r="7565" b="41110"/>
+          <a:stretch>
+            <a:fillRect/>
+          </a:stretch>
+        </p:blipFill>
+        <p:spPr>
+          <a:xfrm>
+            <a:off x="579446" y="3200226"/>
+            <a:ext cx="7733281" cy="1564724"/>
+          </a:xfrm>
+          <a:prstGeom prst="rect">
+            <a:avLst/>
+          </a:prstGeom>
+        </p:spPr>
+      </p:pic>
+      <p:pic>
+        <p:nvPicPr>
+          <p:cNvPr id="12" name="Picture 11">
+            <a:extLst>
+              <a:ext uri="{FF2B5EF4-FFF2-40B4-BE49-F238E27FC236}">
+                <a16:creationId xmlns:a16="http://schemas.microsoft.com/office/drawing/2014/main" id="{A19D36D4-73EA-CE0D-23E9-F12C38BB5448}"/>
+              </a:ext>
+            </a:extLst>
+          </p:cNvPr>
+          <p:cNvPicPr>
+            <a:picLocks noChangeAspect="1"/>
+          </p:cNvPicPr>
+          <p:nvPr/>
+        </p:nvPicPr>
+        <p:blipFill>
+          <a:blip r:embed="rId4"/>
+          <a:srcRect l="27266" t="46665" r="7906" b="26902"/>
+          <a:stretch>
+            <a:fillRect/>
+          </a:stretch>
+        </p:blipFill>
+        <p:spPr>
+          <a:xfrm>
+            <a:off x="579446" y="1105242"/>
+            <a:ext cx="7733281" cy="2011200"/>
+          </a:xfrm>
+          <a:prstGeom prst="rect">
+            <a:avLst/>
+          </a:prstGeom>
+        </p:spPr>
+      </p:pic>
+    </p:spTree>
+    <p:extLst>
+      <p:ext uri="{BB962C8B-B14F-4D97-AF65-F5344CB8AC3E}">
+        <p14:creationId xmlns:p14="http://schemas.microsoft.com/office/powerpoint/2010/main" val="2160127858"/>
+      </p:ext>
+    </p:extLst>
+  </p:cSld>
+  <p:clrMapOvr>
+    <a:masterClrMapping/>
+  </p:clrMapOvr>
+</p:sld>
+</file>
+
+<file path=ppt/slides/slide13.xml><?xml version="1.0" encoding="utf-8"?>
+<p:sld xmlns:a="http://schemas.openxmlformats.org/drawingml/2006/main" xmlns:r="http://schemas.openxmlformats.org/officeDocument/2006/relationships" xmlns:p="http://schemas.openxmlformats.org/presentationml/2006/main">
+  <p:cSld name="Slide 9">
+    <p:bg>
+      <p:bgPr>
+        <a:solidFill>
+          <a:srgbClr val="0F1624"/>
+        </a:solidFill>
+        <a:effectLst/>
+      </p:bgPr>
+    </p:bg>
+    <p:spTree>
+      <p:nvGrpSpPr>
+        <p:cNvPr id="1" name=""/>
+        <p:cNvGrpSpPr/>
+        <p:nvPr/>
+      </p:nvGrpSpPr>
+      <p:grpSpPr>
+        <a:xfrm>
+          <a:off x="0" y="0"/>
+          <a:ext cx="0" cy="0"/>
+          <a:chOff x="0" y="0"/>
+          <a:chExt cx="0" cy="0"/>
+        </a:xfrm>
+      </p:grpSpPr>
+      <p:sp>
+        <p:nvSpPr>
+          <p:cNvPr id="2" name="Text 0"/>
+          <p:cNvSpPr/>
+          <p:nvPr/>
+        </p:nvSpPr>
+        <p:spPr>
+          <a:xfrm>
+            <a:off x="457200" y="256032"/>
+            <a:ext cx="8229600" cy="594360"/>
+          </a:xfrm>
+          <a:prstGeom prst="rect">
+            <a:avLst/>
+          </a:prstGeom>
+          <a:noFill/>
+          <a:ln/>
+        </p:spPr>
+        <p:txBody>
+          <a:bodyPr wrap="square" lIns="0" tIns="0" rIns="0" bIns="0" rtlCol="0" anchor="ctr"/>
+          <a:lstStyle/>
+          <a:p>
+            <a:pPr marL="0" indent="0" algn="l">
+              <a:buNone/>
+            </a:pPr>
+            <a:r>
+              <a:rPr lang="en-US" sz="3200" b="1" dirty="0">
+                <a:solidFill>
+                  <a:srgbClr val="FFFFFF"/>
+                </a:solidFill>
+                <a:latin typeface="Calibri" pitchFamily="34" charset="0"/>
+                <a:ea typeface="Calibri" pitchFamily="34" charset="-122"/>
+                <a:cs typeface="Calibri" pitchFamily="34" charset="-120"/>
+              </a:rPr>
+              <a:t>Git Repository — Branches &amp; Commits</a:t>
+            </a:r>
+            <a:endParaRPr lang="en-US" sz="3200" dirty="0"/>
+          </a:p>
+        </p:txBody>
+      </p:sp>
+      <p:sp>
+        <p:nvSpPr>
+          <p:cNvPr id="3" name="Shape 1"/>
+          <p:cNvSpPr/>
+          <p:nvPr/>
+        </p:nvSpPr>
+        <p:spPr>
+          <a:xfrm>
+            <a:off x="457200" y="877824"/>
+            <a:ext cx="8229600" cy="22860"/>
+          </a:xfrm>
+          <a:prstGeom prst="rect">
+            <a:avLst/>
+          </a:prstGeom>
+          <a:solidFill>
+            <a:srgbClr val="E94560"/>
+          </a:solidFill>
+          <a:ln w="12700">
+            <a:solidFill>
+              <a:srgbClr val="E94560"/>
+            </a:solidFill>
+            <a:prstDash val="solid"/>
+          </a:ln>
+        </p:spPr>
+        <p:txBody>
+          <a:bodyPr/>
+          <a:lstStyle/>
+          <a:p>
+            <a:endParaRPr lang="en-US"/>
+          </a:p>
+        </p:txBody>
+      </p:sp>
+      <p:sp>
+        <p:nvSpPr>
+          <p:cNvPr id="4" name="Shape 2"/>
+          <p:cNvSpPr/>
+          <p:nvPr/>
+        </p:nvSpPr>
+        <p:spPr>
+          <a:xfrm>
+            <a:off x="457200" y="1051560"/>
+            <a:ext cx="8183880" cy="3040380"/>
+          </a:xfrm>
+          <a:prstGeom prst="rect">
+            <a:avLst/>
+          </a:prstGeom>
+          <a:solidFill>
+            <a:srgbClr val="14213D"/>
+          </a:solidFill>
+          <a:ln w="12700">
+            <a:solidFill>
+              <a:srgbClr val="0D9488"/>
+            </a:solidFill>
+            <a:prstDash val="solid"/>
+          </a:ln>
+        </p:spPr>
+        <p:txBody>
+          <a:bodyPr/>
+          <a:lstStyle/>
+          <a:p>
+            <a:endParaRPr lang="en-US"/>
+          </a:p>
+        </p:txBody>
+      </p:sp>
+      <p:sp>
+        <p:nvSpPr>
+          <p:cNvPr id="5" name="Text 3"/>
+          <p:cNvSpPr/>
+          <p:nvPr/>
+        </p:nvSpPr>
+        <p:spPr>
+          <a:xfrm>
+            <a:off x="457200" y="1051560"/>
+            <a:ext cx="8229600" cy="3474720"/>
+          </a:xfrm>
+          <a:prstGeom prst="rect">
+            <a:avLst/>
+          </a:prstGeom>
+          <a:noFill/>
+          <a:ln/>
+        </p:spPr>
+        <p:txBody>
+          <a:bodyPr wrap="square" lIns="0" tIns="0" rIns="0" bIns="0" rtlCol="0" anchor="ctr"/>
+          <a:lstStyle/>
+          <a:p>
+            <a:pPr marL="0" indent="0" algn="ctr">
+              <a:buNone/>
+            </a:pPr>
+            <a:r>
+              <a:rPr lang="en-US" sz="1600" b="1" dirty="0">
+                <a:solidFill>
+                  <a:srgbClr val="B0BEC5"/>
+                </a:solidFill>
+                <a:latin typeface="Calibri" pitchFamily="34" charset="0"/>
+                <a:ea typeface="Calibri" pitchFamily="34" charset="-122"/>
+                <a:cs typeface="Calibri" pitchFamily="34" charset="-120"/>
+              </a:rPr>
+              <a:t>[ Insert GitHub Network graph screenshot here ]</a:t>
+            </a:r>
+            <a:endParaRPr lang="en-US" sz="1600" dirty="0"/>
+          </a:p>
+          <a:p>
+            <a:pPr marL="0" indent="0" algn="ctr">
+              <a:buNone/>
+            </a:pPr>
+            <a:endParaRPr lang="en-US" sz="1600" dirty="0"/>
+          </a:p>
+          <a:p>
+            <a:pPr marL="0" indent="0" algn="ctr">
+              <a:buNone/>
+            </a:pPr>
+            <a:r>
+              <a:rPr lang="en-US" sz="1300" dirty="0">
+                <a:solidFill>
+                  <a:srgbClr val="B0BEC5"/>
+                </a:solidFill>
+                <a:latin typeface="Calibri" pitchFamily="34" charset="0"/>
+                <a:ea typeface="Calibri" pitchFamily="34" charset="-122"/>
+                <a:cs typeface="Calibri" pitchFamily="34" charset="-120"/>
+              </a:rPr>
+              <a:t>Navigate to: GitHub Repo → Insights → Network</a:t>
+            </a:r>
+            <a:endParaRPr lang="en-US" sz="1600" dirty="0"/>
+          </a:p>
+          <a:p>
+            <a:pPr marL="0" indent="0" algn="ctr">
+              <a:buNone/>
+            </a:pPr>
+            <a:r>
+              <a:rPr lang="en-US" sz="1300" dirty="0">
+                <a:solidFill>
+                  <a:srgbClr val="B0BEC5"/>
+                </a:solidFill>
+                <a:latin typeface="Calibri" pitchFamily="34" charset="0"/>
+                <a:ea typeface="Calibri" pitchFamily="34" charset="-122"/>
+                <a:cs typeface="Calibri" pitchFamily="34" charset="-120"/>
+              </a:rPr>
+              <a:t>Take a screenshot and paste it onto this slide.</a:t>
+            </a:r>
+            <a:endParaRPr lang="en-US" sz="1600" dirty="0"/>
+          </a:p>
+        </p:txBody>
+      </p:sp>
+      <p:sp>
+        <p:nvSpPr>
+          <p:cNvPr id="6" name="Text 4"/>
+          <p:cNvSpPr/>
+          <p:nvPr/>
+        </p:nvSpPr>
+        <p:spPr>
+          <a:xfrm>
+            <a:off x="421840" y="4114068"/>
+            <a:ext cx="8138160" cy="365760"/>
+          </a:xfrm>
+          <a:prstGeom prst="rect">
+            <a:avLst/>
+          </a:prstGeom>
+          <a:noFill/>
+          <a:ln/>
+        </p:spPr>
+        <p:txBody>
+          <a:bodyPr wrap="square" rtlCol="0" anchor="t"/>
+          <a:lstStyle/>
+          <a:p>
+            <a:pPr marL="342900" indent="-342900">
+              <a:spcAft>
+                <a:spcPts val="600"/>
+              </a:spcAft>
+              <a:buSzPct val="100000"/>
+              <a:buChar char="•"/>
+            </a:pPr>
+            <a:r>
+              <a:rPr lang="en-US" sz="1100" dirty="0">
+                <a:solidFill>
+                  <a:srgbClr val="B0BEC5"/>
+                </a:solidFill>
+                <a:latin typeface="Calibri" pitchFamily="34" charset="0"/>
+                <a:ea typeface="Calibri" pitchFamily="34" charset="-122"/>
+                <a:cs typeface="Calibri" pitchFamily="34" charset="-120"/>
+              </a:rPr>
+              <a:t>main — stable production branch</a:t>
+            </a:r>
+            <a:endParaRPr lang="en-US" sz="1100" dirty="0"/>
+          </a:p>
+          <a:p>
+            <a:pPr marL="342900" indent="-342900">
+              <a:spcAft>
+                <a:spcPts val="600"/>
+              </a:spcAft>
+              <a:buSzPct val="100000"/>
+              <a:buChar char="•"/>
+            </a:pPr>
+            <a:r>
+              <a:rPr lang="en-US" sz="1100" dirty="0">
+                <a:solidFill>
+                  <a:srgbClr val="B0BEC5"/>
+                </a:solidFill>
+                <a:latin typeface="Calibri" pitchFamily="34" charset="0"/>
+                <a:ea typeface="Calibri" pitchFamily="34" charset="-122"/>
+                <a:cs typeface="Calibri" pitchFamily="34" charset="-120"/>
+              </a:rPr>
+              <a:t>feature/backend — backend API development</a:t>
+            </a:r>
+            <a:endParaRPr lang="en-US" sz="1100" dirty="0"/>
+          </a:p>
+          <a:p>
+            <a:pPr marL="342900" indent="-342900">
+              <a:spcAft>
+                <a:spcPts val="600"/>
+              </a:spcAft>
+              <a:buSzPct val="100000"/>
+              <a:buChar char="•"/>
+            </a:pPr>
+            <a:r>
+              <a:rPr lang="en-US" sz="1100" dirty="0">
+                <a:solidFill>
+                  <a:srgbClr val="B0BEC5"/>
+                </a:solidFill>
+                <a:latin typeface="Calibri" pitchFamily="34" charset="0"/>
+                <a:ea typeface="Calibri" pitchFamily="34" charset="-122"/>
+                <a:cs typeface="Calibri" pitchFamily="34" charset="-120"/>
+              </a:rPr>
+              <a:t>feature/frontend — React SPA development</a:t>
+            </a:r>
+            <a:endParaRPr lang="en-US" sz="1100" dirty="0"/>
+          </a:p>
+          <a:p>
+            <a:pPr marL="342900" indent="-342900">
+              <a:spcAft>
+                <a:spcPts val="600"/>
+              </a:spcAft>
+              <a:buSzPct val="100000"/>
+              <a:buChar char="•"/>
+            </a:pPr>
+            <a:r>
+              <a:rPr lang="en-US" sz="1100" dirty="0">
+                <a:solidFill>
+                  <a:srgbClr val="B0BEC5"/>
+                </a:solidFill>
+                <a:latin typeface="Calibri" pitchFamily="34" charset="0"/>
+                <a:ea typeface="Calibri" pitchFamily="34" charset="-122"/>
+                <a:cs typeface="Calibri" pitchFamily="34" charset="-120"/>
+              </a:rPr>
+              <a:t>fix/* — bug fix branches merged into main via PR</a:t>
+            </a:r>
+            <a:endParaRPr lang="en-US" sz="1100" dirty="0"/>
+          </a:p>
+        </p:txBody>
+      </p:sp>
+      <p:pic>
+        <p:nvPicPr>
+          <p:cNvPr id="8" name="Picture 7" descr="The network graph displays a timeline of recent commits, sorted by date, with the repository owner and various branches (main, frontend, backend, and de-tests).&#10;&#10;AI-generated content may be incorrect.">
+            <a:extLst>
+              <a:ext uri="{FF2B5EF4-FFF2-40B4-BE49-F238E27FC236}">
+                <a16:creationId xmlns:a16="http://schemas.microsoft.com/office/drawing/2014/main" id="{A838B6D8-3658-5004-D0DF-C734115B0206}"/>
+              </a:ext>
+            </a:extLst>
+          </p:cNvPr>
+          <p:cNvPicPr>
+            <a:picLocks noChangeAspect="1"/>
+          </p:cNvPicPr>
+          <p:nvPr/>
+        </p:nvPicPr>
+        <p:blipFill>
+          <a:blip r:embed="rId3"/>
+          <a:stretch>
+            <a:fillRect/>
+          </a:stretch>
+        </p:blipFill>
+        <p:spPr>
+          <a:xfrm>
+            <a:off x="266099" y="952274"/>
+            <a:ext cx="8611802" cy="3138934"/>
+          </a:xfrm>
+          <a:prstGeom prst="rect">
+            <a:avLst/>
+          </a:prstGeom>
+        </p:spPr>
+      </p:pic>
+    </p:spTree>
+  </p:cSld>
+  <p:clrMapOvr>
+    <a:masterClrMapping/>
+  </p:clrMapOvr>
+</p:sld>
+</file>
+
+<file path=ppt/slides/slide14.xml><?xml version="1.0" encoding="utf-8"?>
 <p:sld xmlns:a="http://schemas.openxmlformats.org/drawingml/2006/main" xmlns:r="http://schemas.openxmlformats.org/officeDocument/2006/relationships" xmlns:p="http://schemas.openxmlformats.org/presentationml/2006/main">
   <p:cSld name="Slide 11">
     <p:bg>
@@ -2321,397 +4102,126 @@
           </a:p>
         </p:txBody>
       </p:sp>
-      <p:sp>
-        <p:nvSpPr>
-          <p:cNvPr id="4" name="Shape 2"/>
-          <p:cNvSpPr/>
-          <p:nvPr/>
-        </p:nvSpPr>
-        <p:spPr>
-          <a:xfrm>
-            <a:off x="457200" y="1051560"/>
-            <a:ext cx="3931920" cy="1737360"/>
-          </a:xfrm>
-          <a:prstGeom prst="rect">
-            <a:avLst/>
-          </a:prstGeom>
-          <a:solidFill>
-            <a:srgbClr val="14213D"/>
-          </a:solidFill>
-          <a:ln w="9525">
-            <a:solidFill>
-              <a:srgbClr val="B0BEC5"/>
-            </a:solidFill>
-            <a:prstDash val="solid"/>
-          </a:ln>
-        </p:spPr>
-        <p:txBody>
-          <a:bodyPr/>
-          <a:lstStyle/>
-          <a:p>
-            <a:endParaRPr lang="en-US"/>
-          </a:p>
-        </p:txBody>
-      </p:sp>
-      <p:sp>
-        <p:nvSpPr>
-          <p:cNvPr id="5" name="Text 3"/>
-          <p:cNvSpPr/>
-          <p:nvPr/>
-        </p:nvSpPr>
-        <p:spPr>
-          <a:xfrm>
-            <a:off x="457200" y="1051560"/>
-            <a:ext cx="3931920" cy="1737360"/>
-          </a:xfrm>
-          <a:prstGeom prst="rect">
-            <a:avLst/>
-          </a:prstGeom>
-          <a:noFill/>
-          <a:ln/>
-        </p:spPr>
-        <p:txBody>
-          <a:bodyPr wrap="square" lIns="0" tIns="0" rIns="0" bIns="0" rtlCol="0" anchor="ctr"/>
-          <a:lstStyle/>
-          <a:p>
-            <a:pPr marL="0" indent="0" algn="ctr">
-              <a:buNone/>
-            </a:pPr>
-            <a:r>
-              <a:rPr lang="en-US" sz="1300" i="1" dirty="0">
-                <a:solidFill>
-                  <a:srgbClr val="B0BEC5"/>
-                </a:solidFill>
-                <a:latin typeface="Calibri" pitchFamily="34" charset="0"/>
-                <a:ea typeface="Calibri" pitchFamily="34" charset="-122"/>
-                <a:cs typeface="Calibri" pitchFamily="34" charset="-120"/>
-              </a:rPr>
-              <a:t>Auth Page</a:t>
-            </a:r>
-            <a:endParaRPr lang="en-US" sz="1300" dirty="0"/>
-          </a:p>
-          <a:p>
-            <a:pPr marL="0" indent="0" algn="ctr">
-              <a:buNone/>
-            </a:pPr>
-            <a:r>
-              <a:rPr lang="en-US" sz="1300" i="1" dirty="0">
-                <a:solidFill>
-                  <a:srgbClr val="B0BEC5"/>
-                </a:solidFill>
-                <a:latin typeface="Calibri" pitchFamily="34" charset="0"/>
-                <a:ea typeface="Calibri" pitchFamily="34" charset="-122"/>
-                <a:cs typeface="Calibri" pitchFamily="34" charset="-120"/>
-              </a:rPr>
-              <a:t>(Login / Register)</a:t>
-            </a:r>
-            <a:endParaRPr lang="en-US" sz="1300" dirty="0"/>
-          </a:p>
-        </p:txBody>
-      </p:sp>
-      <p:sp>
-        <p:nvSpPr>
-          <p:cNvPr id="6" name="Shape 4"/>
-          <p:cNvSpPr/>
-          <p:nvPr/>
-        </p:nvSpPr>
-        <p:spPr>
-          <a:xfrm>
-            <a:off x="4572000" y="1051560"/>
-            <a:ext cx="3931920" cy="1737360"/>
-          </a:xfrm>
-          <a:prstGeom prst="rect">
-            <a:avLst/>
-          </a:prstGeom>
-          <a:solidFill>
-            <a:srgbClr val="14213D"/>
-          </a:solidFill>
-          <a:ln w="9525">
-            <a:solidFill>
-              <a:srgbClr val="B0BEC5"/>
-            </a:solidFill>
-            <a:prstDash val="solid"/>
-          </a:ln>
-        </p:spPr>
-        <p:txBody>
-          <a:bodyPr/>
-          <a:lstStyle/>
-          <a:p>
-            <a:endParaRPr lang="en-US"/>
-          </a:p>
-        </p:txBody>
-      </p:sp>
-      <p:sp>
-        <p:nvSpPr>
-          <p:cNvPr id="7" name="Text 5"/>
-          <p:cNvSpPr/>
-          <p:nvPr/>
-        </p:nvSpPr>
-        <p:spPr>
-          <a:xfrm>
-            <a:off x="4572000" y="1051560"/>
-            <a:ext cx="3931920" cy="1737360"/>
-          </a:xfrm>
-          <a:prstGeom prst="rect">
-            <a:avLst/>
-          </a:prstGeom>
-          <a:noFill/>
-          <a:ln/>
-        </p:spPr>
-        <p:txBody>
-          <a:bodyPr wrap="square" lIns="0" tIns="0" rIns="0" bIns="0" rtlCol="0" anchor="ctr"/>
-          <a:lstStyle/>
-          <a:p>
-            <a:pPr marL="0" indent="0" algn="ctr">
-              <a:buNone/>
-            </a:pPr>
-            <a:r>
-              <a:rPr lang="en-US" sz="1300" i="1" dirty="0">
-                <a:solidFill>
-                  <a:srgbClr val="B0BEC5"/>
-                </a:solidFill>
-                <a:latin typeface="Calibri" pitchFamily="34" charset="0"/>
-                <a:ea typeface="Calibri" pitchFamily="34" charset="-122"/>
-                <a:cs typeface="Calibri" pitchFamily="34" charset="-120"/>
-              </a:rPr>
-              <a:t>HomePage</a:t>
-            </a:r>
-            <a:endParaRPr lang="en-US" sz="1300" dirty="0"/>
-          </a:p>
-          <a:p>
-            <a:pPr marL="0" indent="0" algn="ctr">
-              <a:buNone/>
-            </a:pPr>
-            <a:r>
-              <a:rPr lang="en-US" sz="1300" i="1" dirty="0">
-                <a:solidFill>
-                  <a:srgbClr val="B0BEC5"/>
-                </a:solidFill>
-                <a:latin typeface="Calibri" pitchFamily="34" charset="0"/>
-                <a:ea typeface="Calibri" pitchFamily="34" charset="-122"/>
-                <a:cs typeface="Calibri" pitchFamily="34" charset="-120"/>
-              </a:rPr>
-              <a:t>(Groups + Friends rail)</a:t>
-            </a:r>
-            <a:endParaRPr lang="en-US" sz="1300" dirty="0"/>
-          </a:p>
-        </p:txBody>
-      </p:sp>
-      <p:sp>
-        <p:nvSpPr>
-          <p:cNvPr id="8" name="Shape 6"/>
-          <p:cNvSpPr/>
-          <p:nvPr/>
-        </p:nvSpPr>
-        <p:spPr>
-          <a:xfrm>
-            <a:off x="457200" y="2880360"/>
-            <a:ext cx="3931920" cy="1737360"/>
-          </a:xfrm>
-          <a:prstGeom prst="rect">
-            <a:avLst/>
-          </a:prstGeom>
-          <a:solidFill>
-            <a:srgbClr val="14213D"/>
-          </a:solidFill>
-          <a:ln w="9525">
-            <a:solidFill>
-              <a:srgbClr val="B0BEC5"/>
-            </a:solidFill>
-            <a:prstDash val="solid"/>
-          </a:ln>
-        </p:spPr>
-        <p:txBody>
-          <a:bodyPr/>
-          <a:lstStyle/>
-          <a:p>
-            <a:endParaRPr lang="en-US"/>
-          </a:p>
-        </p:txBody>
-      </p:sp>
-      <p:sp>
-        <p:nvSpPr>
-          <p:cNvPr id="9" name="Text 7"/>
-          <p:cNvSpPr/>
-          <p:nvPr/>
-        </p:nvSpPr>
-        <p:spPr>
-          <a:xfrm>
-            <a:off x="457200" y="2880360"/>
-            <a:ext cx="3931920" cy="1737360"/>
-          </a:xfrm>
-          <a:prstGeom prst="rect">
-            <a:avLst/>
-          </a:prstGeom>
-          <a:noFill/>
-          <a:ln/>
-        </p:spPr>
-        <p:txBody>
-          <a:bodyPr wrap="square" lIns="0" tIns="0" rIns="0" bIns="0" rtlCol="0" anchor="ctr"/>
-          <a:lstStyle/>
-          <a:p>
-            <a:pPr marL="0" indent="0" algn="ctr">
-              <a:buNone/>
-            </a:pPr>
-            <a:r>
-              <a:rPr lang="en-US" sz="1300" i="1" dirty="0">
-                <a:solidFill>
-                  <a:srgbClr val="B0BEC5"/>
-                </a:solidFill>
-                <a:latin typeface="Calibri" pitchFamily="34" charset="0"/>
-                <a:ea typeface="Calibri" pitchFamily="34" charset="-122"/>
-                <a:cs typeface="Calibri" pitchFamily="34" charset="-120"/>
-              </a:rPr>
-              <a:t>GroupDetailPage</a:t>
-            </a:r>
-            <a:endParaRPr lang="en-US" sz="1300" dirty="0"/>
-          </a:p>
-          <a:p>
-            <a:pPr marL="0" indent="0" algn="ctr">
-              <a:buNone/>
-            </a:pPr>
-            <a:r>
-              <a:rPr lang="en-US" sz="1300" i="1" dirty="0">
-                <a:solidFill>
-                  <a:srgbClr val="B0BEC5"/>
-                </a:solidFill>
-                <a:latin typeface="Calibri" pitchFamily="34" charset="0"/>
-                <a:ea typeface="Calibri" pitchFamily="34" charset="-122"/>
-                <a:cs typeface="Calibri" pitchFamily="34" charset="-120"/>
-              </a:rPr>
-              <a:t>(Sessions + Voting)</a:t>
-            </a:r>
-            <a:endParaRPr lang="en-US" sz="1300" dirty="0"/>
-          </a:p>
-        </p:txBody>
-      </p:sp>
-      <p:sp>
-        <p:nvSpPr>
-          <p:cNvPr id="10" name="Shape 8"/>
-          <p:cNvSpPr/>
-          <p:nvPr/>
-        </p:nvSpPr>
-        <p:spPr>
-          <a:xfrm>
-            <a:off x="4572000" y="2880360"/>
-            <a:ext cx="3931920" cy="1737360"/>
-          </a:xfrm>
-          <a:prstGeom prst="rect">
-            <a:avLst/>
-          </a:prstGeom>
-          <a:solidFill>
-            <a:srgbClr val="14213D"/>
-          </a:solidFill>
-          <a:ln w="9525">
-            <a:solidFill>
-              <a:srgbClr val="B0BEC5"/>
-            </a:solidFill>
-            <a:prstDash val="solid"/>
-          </a:ln>
-        </p:spPr>
-        <p:txBody>
-          <a:bodyPr/>
-          <a:lstStyle/>
-          <a:p>
-            <a:endParaRPr lang="en-US"/>
-          </a:p>
-        </p:txBody>
-      </p:sp>
-      <p:sp>
-        <p:nvSpPr>
-          <p:cNvPr id="11" name="Text 9"/>
-          <p:cNvSpPr/>
-          <p:nvPr/>
-        </p:nvSpPr>
-        <p:spPr>
-          <a:xfrm>
-            <a:off x="4572000" y="2880360"/>
-            <a:ext cx="3931920" cy="1737360"/>
-          </a:xfrm>
-          <a:prstGeom prst="rect">
-            <a:avLst/>
-          </a:prstGeom>
-          <a:noFill/>
-          <a:ln/>
-        </p:spPr>
-        <p:txBody>
-          <a:bodyPr wrap="square" lIns="0" tIns="0" rIns="0" bIns="0" rtlCol="0" anchor="ctr"/>
-          <a:lstStyle/>
-          <a:p>
-            <a:pPr marL="0" indent="0" algn="ctr">
-              <a:buNone/>
-            </a:pPr>
-            <a:r>
-              <a:rPr lang="en-US" sz="1300" i="1" dirty="0">
-                <a:solidFill>
-                  <a:srgbClr val="B0BEC5"/>
-                </a:solidFill>
-                <a:latin typeface="Calibri" pitchFamily="34" charset="0"/>
-                <a:ea typeface="Calibri" pitchFamily="34" charset="-122"/>
-                <a:cs typeface="Calibri" pitchFamily="34" charset="-120"/>
-              </a:rPr>
-              <a:t>Recommendations Tab</a:t>
-            </a:r>
-            <a:endParaRPr lang="en-US" sz="1300" dirty="0"/>
-          </a:p>
-          <a:p>
-            <a:pPr marL="0" indent="0" algn="ctr">
-              <a:buNone/>
-            </a:pPr>
-            <a:r>
-              <a:rPr lang="en-US" sz="1300" i="1" dirty="0">
-                <a:solidFill>
-                  <a:srgbClr val="B0BEC5"/>
-                </a:solidFill>
-                <a:latin typeface="Calibri" pitchFamily="34" charset="0"/>
-                <a:ea typeface="Calibri" pitchFamily="34" charset="-122"/>
-                <a:cs typeface="Calibri" pitchFamily="34" charset="-120"/>
-              </a:rPr>
-              <a:t>(AI suggestions + scores)</a:t>
-            </a:r>
-            <a:endParaRPr lang="en-US" sz="1300" dirty="0"/>
-          </a:p>
-        </p:txBody>
-      </p:sp>
-      <p:sp>
-        <p:nvSpPr>
-          <p:cNvPr id="12" name="Text 10"/>
-          <p:cNvSpPr/>
-          <p:nvPr/>
-        </p:nvSpPr>
-        <p:spPr>
-          <a:xfrm>
-            <a:off x="457200" y="4709160"/>
-            <a:ext cx="8229600" cy="274320"/>
-          </a:xfrm>
-          <a:prstGeom prst="rect">
-            <a:avLst/>
-          </a:prstGeom>
-          <a:noFill/>
-          <a:ln/>
-        </p:spPr>
-        <p:txBody>
-          <a:bodyPr wrap="square" lIns="0" tIns="0" rIns="0" bIns="0" rtlCol="0" anchor="ctr"/>
-          <a:lstStyle/>
-          <a:p>
-            <a:pPr marL="0" indent="0" algn="ctr">
-              <a:buNone/>
-            </a:pPr>
-            <a:r>
-              <a:rPr lang="en-US" sz="1000" i="1" dirty="0">
-                <a:solidFill>
-                  <a:srgbClr val="B0BEC5"/>
-                </a:solidFill>
-                <a:latin typeface="Calibri" pitchFamily="34" charset="0"/>
-                <a:ea typeface="Calibri" pitchFamily="34" charset="-122"/>
-                <a:cs typeface="Calibri" pitchFamily="34" charset="-120"/>
-              </a:rPr>
-              <a:t>Replace placeholders above with screenshots taken from the running app</a:t>
-            </a:r>
-            <a:endParaRPr lang="en-US" sz="1000" dirty="0"/>
-          </a:p>
-        </p:txBody>
-      </p:sp>
+      <p:pic>
+        <p:nvPicPr>
+          <p:cNvPr id="14" name="Picture 13" descr="The image displays a user interface with a welcome back message, fields for username and password, and options for account creation and login, powered by a backend API and MongoDB.&#10;&#10;AI-generated content may be incorrect.">
+            <a:extLst>
+              <a:ext uri="{FF2B5EF4-FFF2-40B4-BE49-F238E27FC236}">
+                <a16:creationId xmlns:a16="http://schemas.microsoft.com/office/drawing/2014/main" id="{AA2EE0A6-D049-B583-A544-5425A292B36A}"/>
+              </a:ext>
+            </a:extLst>
+          </p:cNvPr>
+          <p:cNvPicPr>
+            <a:picLocks noChangeAspect="1"/>
+          </p:cNvPicPr>
+          <p:nvPr/>
+        </p:nvPicPr>
+        <p:blipFill>
+          <a:blip r:embed="rId3"/>
+          <a:stretch>
+            <a:fillRect/>
+          </a:stretch>
+        </p:blipFill>
+        <p:spPr>
+          <a:xfrm>
+            <a:off x="445001" y="1028699"/>
+            <a:ext cx="3824131" cy="1877707"/>
+          </a:xfrm>
+          <a:prstGeom prst="rect">
+            <a:avLst/>
+          </a:prstGeom>
+        </p:spPr>
+      </p:pic>
+      <p:pic>
+        <p:nvPicPr>
+          <p:cNvPr id="16" name="Picture 15" descr="The image is a user interface for a social platform showing a list of various groups, their status (public or private), membership count, and options to join or request to join.&#10;&#10;AI-generated content may be incorrect.">
+            <a:extLst>
+              <a:ext uri="{FF2B5EF4-FFF2-40B4-BE49-F238E27FC236}">
+                <a16:creationId xmlns:a16="http://schemas.microsoft.com/office/drawing/2014/main" id="{EA7F72D4-D924-926E-D1B6-52CF0BC09423}"/>
+              </a:ext>
+            </a:extLst>
+          </p:cNvPr>
+          <p:cNvPicPr>
+            <a:picLocks noChangeAspect="1"/>
+          </p:cNvPicPr>
+          <p:nvPr/>
+        </p:nvPicPr>
+        <p:blipFill>
+          <a:blip r:embed="rId4"/>
+          <a:stretch>
+            <a:fillRect/>
+          </a:stretch>
+        </p:blipFill>
+        <p:spPr>
+          <a:xfrm>
+            <a:off x="457200" y="3014624"/>
+            <a:ext cx="3811932" cy="2027831"/>
+          </a:xfrm>
+          <a:prstGeom prst="rect">
+            <a:avLst/>
+          </a:prstGeom>
+        </p:spPr>
+      </p:pic>
+      <p:pic>
+        <p:nvPicPr>
+          <p:cNvPr id="18" name="Picture 17" descr="Pick Your Status&#10;&#10;AI-generated content may be incorrect.">
+            <a:extLst>
+              <a:ext uri="{FF2B5EF4-FFF2-40B4-BE49-F238E27FC236}">
+                <a16:creationId xmlns:a16="http://schemas.microsoft.com/office/drawing/2014/main" id="{2FAD4855-69EA-1F4F-D827-08EA6B69DB00}"/>
+              </a:ext>
+            </a:extLst>
+          </p:cNvPr>
+          <p:cNvPicPr>
+            <a:picLocks noChangeAspect="1"/>
+          </p:cNvPicPr>
+          <p:nvPr/>
+        </p:nvPicPr>
+        <p:blipFill>
+          <a:blip r:embed="rId5"/>
+          <a:stretch>
+            <a:fillRect/>
+          </a:stretch>
+        </p:blipFill>
+        <p:spPr>
+          <a:xfrm>
+            <a:off x="4499979" y="986019"/>
+            <a:ext cx="3918627" cy="1920387"/>
+          </a:xfrm>
+          <a:prstGeom prst="rect">
+            <a:avLst/>
+          </a:prstGeom>
+        </p:spPr>
+      </p:pic>
+      <p:pic>
+        <p:nvPicPr>
+          <p:cNvPr id="20" name="Picture 19" descr="The image displays a black chat interface with a list of movie titles, ratings, and various options for group chat management.&#10;&#10;AI-generated content may be incorrect.">
+            <a:extLst>
+              <a:ext uri="{FF2B5EF4-FFF2-40B4-BE49-F238E27FC236}">
+                <a16:creationId xmlns:a16="http://schemas.microsoft.com/office/drawing/2014/main" id="{F67DAE0E-854B-3C80-7B14-279B77C2E10C}"/>
+              </a:ext>
+            </a:extLst>
+          </p:cNvPr>
+          <p:cNvPicPr>
+            <a:picLocks noChangeAspect="1"/>
+          </p:cNvPicPr>
+          <p:nvPr/>
+        </p:nvPicPr>
+        <p:blipFill>
+          <a:blip r:embed="rId6"/>
+          <a:stretch>
+            <a:fillRect/>
+          </a:stretch>
+        </p:blipFill>
+        <p:spPr>
+          <a:xfrm>
+            <a:off x="4499979" y="3034443"/>
+            <a:ext cx="3918627" cy="1940206"/>
+          </a:xfrm>
+          <a:prstGeom prst="rect">
+            <a:avLst/>
+          </a:prstGeom>
+        </p:spPr>
+      </p:pic>
     </p:spTree>
   </p:cSld>
   <p:clrMapOvr>
@@ -2720,7 +4230,7 @@
 </p:sld>
 </file>
 
-<file path=ppt/slides/slide12.xml><?xml version="1.0" encoding="utf-8"?>
+<file path=ppt/slides/slide15.xml><?xml version="1.0" encoding="utf-8"?>
 <p:sld xmlns:a="http://schemas.openxmlformats.org/drawingml/2006/main" xmlns:r="http://schemas.openxmlformats.org/officeDocument/2006/relationships" xmlns:p="http://schemas.openxmlformats.org/presentationml/2006/main">
   <p:cSld name="Slide 12">
     <p:bg>
@@ -3000,7 +4510,7 @@
                 <a:ea typeface="Calibri" pitchFamily="34" charset="-122"/>
                 <a:cs typeface="Calibri" pitchFamily="34" charset="-120"/>
               </a:rPr>
-              <a:t>Vitest unit tests: JWT utilities, Zod DTOs, schema, and React components</a:t>
+              <a:t>Vitest unit tests: JWT utilities, DTOs, schema, and React components</a:t>
             </a:r>
             <a:endParaRPr lang="en-US" sz="1450" dirty="0"/>
           </a:p>
@@ -3576,45 +5086,12 @@
             <a:endParaRPr lang="en-US" sz="1400" dirty="0"/>
           </a:p>
           <a:p>
-            <a:pPr marL="342900" indent="-342900">
+            <a:pPr>
               <a:spcAft>
                 <a:spcPts val="600"/>
               </a:spcAft>
               <a:buSzPct val="100000"/>
-              <a:buChar char="•"/>
-            </a:pPr>
-            <a:r>
-              <a:rPr lang="en-US" sz="1400" dirty="0">
-                <a:solidFill>
-                  <a:srgbClr val="E8EAF0"/>
-                </a:solidFill>
-                <a:latin typeface="Calibri" pitchFamily="34" charset="0"/>
-                <a:ea typeface="Calibri" pitchFamily="34" charset="-122"/>
-                <a:cs typeface="Calibri" pitchFamily="34" charset="-120"/>
-              </a:rPr>
-              <a:t>Fetch API with httpOnly cookie auth</a:t>
-            </a:r>
-            <a:endParaRPr lang="en-US" sz="1400" dirty="0"/>
-          </a:p>
-          <a:p>
-            <a:pPr marL="342900" indent="-342900">
-              <a:spcAft>
-                <a:spcPts val="600"/>
-              </a:spcAft>
-              <a:buSzPct val="100000"/>
-              <a:buChar char="•"/>
-            </a:pPr>
-            <a:r>
-              <a:rPr lang="en-US" sz="1400" dirty="0">
-                <a:solidFill>
-                  <a:srgbClr val="E8EAF0"/>
-                </a:solidFill>
-                <a:latin typeface="Calibri" pitchFamily="34" charset="0"/>
-                <a:ea typeface="Calibri" pitchFamily="34" charset="-122"/>
-                <a:cs typeface="Calibri" pitchFamily="34" charset="-120"/>
-              </a:rPr>
-              <a:t>Component-based SPA (single-page app)</a:t>
-            </a:r>
+            </a:pPr>
             <a:endParaRPr lang="en-US" sz="1400" dirty="0"/>
           </a:p>
         </p:txBody>
@@ -3770,48 +5247,6 @@
                 <a:cs typeface="Calibri" pitchFamily="34" charset="-120"/>
               </a:rPr>
               <a:t>JWT access + refresh token auth</a:t>
-            </a:r>
-            <a:endParaRPr lang="en-US" sz="1400" dirty="0"/>
-          </a:p>
-          <a:p>
-            <a:pPr marL="342900" indent="-342900">
-              <a:spcAft>
-                <a:spcPts val="600"/>
-              </a:spcAft>
-              <a:buSzPct val="100000"/>
-              <a:buChar char="•"/>
-            </a:pPr>
-            <a:r>
-              <a:rPr lang="en-US" sz="1400" dirty="0">
-                <a:solidFill>
-                  <a:srgbClr val="E8EAF0"/>
-                </a:solidFill>
-                <a:latin typeface="Calibri" pitchFamily="34" charset="0"/>
-                <a:ea typeface="Calibri" pitchFamily="34" charset="-122"/>
-                <a:cs typeface="Calibri" pitchFamily="34" charset="-120"/>
-              </a:rPr>
-              <a:t>Zod schema validation</a:t>
-            </a:r>
-            <a:endParaRPr lang="en-US" sz="1400" dirty="0"/>
-          </a:p>
-          <a:p>
-            <a:pPr marL="342900" indent="-342900">
-              <a:spcAft>
-                <a:spcPts val="600"/>
-              </a:spcAft>
-              <a:buSzPct val="100000"/>
-              <a:buChar char="•"/>
-            </a:pPr>
-            <a:r>
-              <a:rPr lang="en-US" sz="1400" dirty="0">
-                <a:solidFill>
-                  <a:srgbClr val="E8EAF0"/>
-                </a:solidFill>
-                <a:latin typeface="Calibri" pitchFamily="34" charset="0"/>
-                <a:ea typeface="Calibri" pitchFamily="34" charset="-122"/>
-                <a:cs typeface="Calibri" pitchFamily="34" charset="-120"/>
-              </a:rPr>
-              <a:t>OpenAI API (recommendations)</a:t>
             </a:r>
             <a:endParaRPr lang="en-US" sz="1400" dirty="0"/>
           </a:p>
@@ -4712,6 +6147,163 @@
 
 <file path=ppt/slides/slide5.xml><?xml version="1.0" encoding="utf-8"?>
 <p:sld xmlns:a="http://schemas.openxmlformats.org/drawingml/2006/main" xmlns:r="http://schemas.openxmlformats.org/officeDocument/2006/relationships" xmlns:p="http://schemas.openxmlformats.org/presentationml/2006/main">
+  <p:cSld>
+    <p:bg>
+      <p:bgPr>
+        <a:solidFill>
+          <a:srgbClr val="0F1624"/>
+        </a:solidFill>
+        <a:effectLst/>
+      </p:bgPr>
+    </p:bg>
+    <p:spTree>
+      <p:nvGrpSpPr>
+        <p:cNvPr id="1" name="">
+          <a:extLst>
+            <a:ext uri="{FF2B5EF4-FFF2-40B4-BE49-F238E27FC236}">
+              <a16:creationId xmlns:a16="http://schemas.microsoft.com/office/drawing/2014/main" id="{9AF07A80-7424-D880-E0BE-92F172EA660A}"/>
+            </a:ext>
+          </a:extLst>
+        </p:cNvPr>
+        <p:cNvGrpSpPr/>
+        <p:nvPr/>
+      </p:nvGrpSpPr>
+      <p:grpSpPr>
+        <a:xfrm>
+          <a:off x="0" y="0"/>
+          <a:ext cx="0" cy="0"/>
+          <a:chOff x="0" y="0"/>
+          <a:chExt cx="0" cy="0"/>
+        </a:xfrm>
+      </p:grpSpPr>
+      <p:sp>
+        <p:nvSpPr>
+          <p:cNvPr id="2" name="Text 0">
+            <a:extLst>
+              <a:ext uri="{FF2B5EF4-FFF2-40B4-BE49-F238E27FC236}">
+                <a16:creationId xmlns:a16="http://schemas.microsoft.com/office/drawing/2014/main" id="{672EDEA2-43A9-1899-FD81-8DF857C66FC8}"/>
+              </a:ext>
+            </a:extLst>
+          </p:cNvPr>
+          <p:cNvSpPr/>
+          <p:nvPr/>
+        </p:nvSpPr>
+        <p:spPr>
+          <a:xfrm>
+            <a:off x="457200" y="256032"/>
+            <a:ext cx="8229600" cy="594360"/>
+          </a:xfrm>
+          <a:prstGeom prst="rect">
+            <a:avLst/>
+          </a:prstGeom>
+          <a:noFill/>
+          <a:ln/>
+        </p:spPr>
+        <p:txBody>
+          <a:bodyPr wrap="square" lIns="0" tIns="0" rIns="0" bIns="0" rtlCol="0" anchor="ctr"/>
+          <a:lstStyle/>
+          <a:p>
+            <a:pPr marL="0" indent="0" algn="l">
+              <a:buNone/>
+            </a:pPr>
+            <a:r>
+              <a:rPr lang="en-US" sz="3200" b="1" dirty="0">
+                <a:solidFill>
+                  <a:srgbClr val="FFFFFF"/>
+                </a:solidFill>
+                <a:latin typeface="Calibri" pitchFamily="34" charset="0"/>
+                <a:ea typeface="Calibri" pitchFamily="34" charset="-122"/>
+                <a:cs typeface="Calibri" pitchFamily="34" charset="-120"/>
+              </a:rPr>
+              <a:t>UML Class Diagram</a:t>
+            </a:r>
+            <a:endParaRPr lang="en-US" sz="3200" dirty="0"/>
+          </a:p>
+        </p:txBody>
+      </p:sp>
+      <p:sp>
+        <p:nvSpPr>
+          <p:cNvPr id="3" name="Shape 1">
+            <a:extLst>
+              <a:ext uri="{FF2B5EF4-FFF2-40B4-BE49-F238E27FC236}">
+                <a16:creationId xmlns:a16="http://schemas.microsoft.com/office/drawing/2014/main" id="{3CBA25B5-0623-C3EE-C1A6-AD80D2997072}"/>
+              </a:ext>
+            </a:extLst>
+          </p:cNvPr>
+          <p:cNvSpPr/>
+          <p:nvPr/>
+        </p:nvSpPr>
+        <p:spPr>
+          <a:xfrm>
+            <a:off x="457200" y="877824"/>
+            <a:ext cx="8229600" cy="22860"/>
+          </a:xfrm>
+          <a:prstGeom prst="rect">
+            <a:avLst/>
+          </a:prstGeom>
+          <a:solidFill>
+            <a:srgbClr val="E94560"/>
+          </a:solidFill>
+          <a:ln w="12700">
+            <a:solidFill>
+              <a:srgbClr val="E94560"/>
+            </a:solidFill>
+            <a:prstDash val="solid"/>
+          </a:ln>
+        </p:spPr>
+        <p:txBody>
+          <a:bodyPr/>
+          <a:lstStyle/>
+          <a:p>
+            <a:endParaRPr lang="en-US"/>
+          </a:p>
+        </p:txBody>
+      </p:sp>
+      <p:pic>
+        <p:nvPicPr>
+          <p:cNvPr id="43" name="Picture 42" descr="The diagram appears to be a complex hierarchical data structure, possibly representing a database schema or a data model for a user management system. It includes various roles, user attributes, and relationships such as system roles, preferences, friendships, group invites, and watchlists.&#10;&#10;AI-generated content may be incorrect.">
+            <a:extLst>
+              <a:ext uri="{FF2B5EF4-FFF2-40B4-BE49-F238E27FC236}">
+                <a16:creationId xmlns:a16="http://schemas.microsoft.com/office/drawing/2014/main" id="{B25B2943-499C-4326-C36E-0C0C1C2180C5}"/>
+              </a:ext>
+            </a:extLst>
+          </p:cNvPr>
+          <p:cNvPicPr>
+            <a:picLocks noChangeAspect="1"/>
+          </p:cNvPicPr>
+          <p:nvPr/>
+        </p:nvPicPr>
+        <p:blipFill>
+          <a:blip r:embed="rId3"/>
+          <a:stretch>
+            <a:fillRect/>
+          </a:stretch>
+        </p:blipFill>
+        <p:spPr>
+          <a:xfrm>
+            <a:off x="621144" y="1073406"/>
+            <a:ext cx="7581429" cy="3905120"/>
+          </a:xfrm>
+          <a:prstGeom prst="rect">
+            <a:avLst/>
+          </a:prstGeom>
+        </p:spPr>
+      </p:pic>
+    </p:spTree>
+    <p:extLst>
+      <p:ext uri="{BB962C8B-B14F-4D97-AF65-F5344CB8AC3E}">
+        <p14:creationId xmlns:p14="http://schemas.microsoft.com/office/powerpoint/2010/main" val="503184617"/>
+      </p:ext>
+    </p:extLst>
+  </p:cSld>
+  <p:clrMapOvr>
+    <a:masterClrMapping/>
+  </p:clrMapOvr>
+</p:sld>
+</file>
+
+<file path=ppt/slides/slide6.xml><?xml version="1.0" encoding="utf-8"?>
+<p:sld xmlns:a="http://schemas.openxmlformats.org/drawingml/2006/main" xmlns:r="http://schemas.openxmlformats.org/officeDocument/2006/relationships" xmlns:p="http://schemas.openxmlformats.org/presentationml/2006/main">
   <p:cSld name="Slide 5">
     <p:bg>
       <p:bgPr>
@@ -5485,7 +7077,29 @@
                 <a:ea typeface="Calibri" pitchFamily="34" charset="-122"/>
                 <a:cs typeface="Calibri" pitchFamily="34" charset="-120"/>
               </a:rPr>
-              <a:t>groupId · scheduledAt · movieTmdbId?</a:t>
+              <a:t>groupId · </a:t>
+            </a:r>
+            <a:r>
+              <a:rPr lang="en-US" sz="950" dirty="0" err="1">
+                <a:solidFill>
+                  <a:srgbClr val="E8EAF0"/>
+                </a:solidFill>
+                <a:latin typeface="Calibri" pitchFamily="34" charset="0"/>
+                <a:ea typeface="Calibri" pitchFamily="34" charset="-122"/>
+                <a:cs typeface="Calibri" pitchFamily="34" charset="-120"/>
+              </a:rPr>
+              <a:t>scheduledAt</a:t>
+            </a:r>
+            <a:r>
+              <a:rPr lang="en-US" sz="950" dirty="0">
+                <a:solidFill>
+                  <a:srgbClr val="E8EAF0"/>
+                </a:solidFill>
+                <a:latin typeface="Calibri" pitchFamily="34" charset="0"/>
+                <a:ea typeface="Calibri" pitchFamily="34" charset="-122"/>
+                <a:cs typeface="Calibri" pitchFamily="34" charset="-120"/>
+              </a:rPr>
+              <a:t> </a:t>
             </a:r>
             <a:endParaRPr lang="en-US" sz="950" dirty="0"/>
           </a:p>
@@ -6120,7 +7734,7 @@
 </p:sld>
 </file>
 
-<file path=ppt/slides/slide6.xml><?xml version="1.0" encoding="utf-8"?>
+<file path=ppt/slides/slide7.xml><?xml version="1.0" encoding="utf-8"?>
 <p:sld xmlns:a="http://schemas.openxmlformats.org/drawingml/2006/main" xmlns:r="http://schemas.openxmlformats.org/officeDocument/2006/relationships" xmlns:p="http://schemas.openxmlformats.org/presentationml/2006/main">
   <p:cSld name="Slide 6">
     <p:bg>
@@ -6299,7 +7913,7 @@
         </p:nvSpPr>
         <p:spPr>
           <a:xfrm>
-            <a:off x="3566160" y="1281488"/>
+            <a:off x="4709160" y="1434954"/>
             <a:ext cx="2286000" cy="640080"/>
           </a:xfrm>
           <a:prstGeom prst="roundRect">
@@ -6335,7 +7949,7 @@
         </p:nvSpPr>
         <p:spPr>
           <a:xfrm>
-            <a:off x="3566160" y="1280160"/>
+            <a:off x="4709160" y="1434954"/>
             <a:ext cx="2286000" cy="640080"/>
           </a:xfrm>
           <a:prstGeom prst="rect">
@@ -6448,9 +8062,9 @@
           <p:nvPr/>
         </p:nvSpPr>
         <p:spPr>
-          <a:xfrm>
-            <a:off x="2743200" y="1463040"/>
-            <a:ext cx="822960" cy="0"/>
+          <a:xfrm flipV="1">
+            <a:off x="2743200" y="1520454"/>
+            <a:ext cx="1965960" cy="11164"/>
           </a:xfrm>
           <a:prstGeom prst="line">
             <a:avLst/>
@@ -6479,7 +8093,7 @@
         </p:nvSpPr>
         <p:spPr>
           <a:xfrm>
-            <a:off x="2148840" y="1274553"/>
+            <a:off x="2603646" y="1266843"/>
             <a:ext cx="2011680" cy="228600"/>
           </a:xfrm>
           <a:prstGeom prst="rect">
@@ -6517,9 +8131,9 @@
           <p:nvPr/>
         </p:nvSpPr>
         <p:spPr>
-          <a:xfrm>
-            <a:off x="2743200" y="1828800"/>
-            <a:ext cx="822960" cy="0"/>
+          <a:xfrm flipV="1">
+            <a:off x="2743200" y="1828798"/>
+            <a:ext cx="1965960" cy="0"/>
           </a:xfrm>
           <a:prstGeom prst="line">
             <a:avLst/>
@@ -6549,7 +8163,7 @@
         <p:spPr>
           <a:xfrm>
             <a:off x="2148840" y="1635886"/>
-            <a:ext cx="2011680" cy="228600"/>
+            <a:ext cx="2423160" cy="228600"/>
           </a:xfrm>
           <a:prstGeom prst="rect">
             <a:avLst/>
@@ -6587,7 +8201,7 @@
         </p:nvSpPr>
         <p:spPr>
           <a:xfrm>
-            <a:off x="5852160" y="1600200"/>
+            <a:off x="5852160" y="2079781"/>
             <a:ext cx="0" cy="1325880"/>
           </a:xfrm>
           <a:prstGeom prst="line">
@@ -6617,7 +8231,7 @@
         </p:nvSpPr>
         <p:spPr>
           <a:xfrm>
-            <a:off x="5512976" y="2173816"/>
+            <a:off x="5479464" y="2417924"/>
             <a:ext cx="2011680" cy="228600"/>
           </a:xfrm>
           <a:prstGeom prst="rect">
@@ -6656,8 +8270,8 @@
         </p:nvSpPr>
         <p:spPr>
           <a:xfrm>
-            <a:off x="3566160" y="3361546"/>
-            <a:ext cx="2286000" cy="0"/>
+            <a:off x="5486402" y="2079781"/>
+            <a:ext cx="0" cy="840735"/>
           </a:xfrm>
           <a:prstGeom prst="line">
             <a:avLst/>
@@ -6686,7 +8300,7 @@
         </p:nvSpPr>
         <p:spPr>
           <a:xfrm>
-            <a:off x="3474720" y="2709968"/>
+            <a:off x="3839322" y="2414890"/>
             <a:ext cx="2468880" cy="228600"/>
           </a:xfrm>
           <a:prstGeom prst="rect">
@@ -6725,8 +8339,8 @@
         </p:nvSpPr>
         <p:spPr>
           <a:xfrm>
-            <a:off x="457200" y="3246120"/>
-            <a:ext cx="3108960" cy="0"/>
+            <a:off x="1545218" y="3223257"/>
+            <a:ext cx="2020941" cy="22863"/>
           </a:xfrm>
           <a:prstGeom prst="line">
             <a:avLst/>
@@ -6755,8 +8369,8 @@
         </p:nvSpPr>
         <p:spPr>
           <a:xfrm>
-            <a:off x="365760" y="3017520"/>
-            <a:ext cx="3291840" cy="228600"/>
+            <a:off x="787078" y="3017520"/>
+            <a:ext cx="2870521" cy="228600"/>
           </a:xfrm>
           <a:prstGeom prst="rect">
             <a:avLst/>
@@ -6910,6 +8524,42 @@
               <a:t>Refresh token is one-time-use: rotation prevents stolen-token replay attacks</a:t>
             </a:r>
             <a:endParaRPr lang="en-US" sz="1200" dirty="0"/>
+          </a:p>
+        </p:txBody>
+      </p:sp>
+      <p:sp>
+        <p:nvSpPr>
+          <p:cNvPr id="21" name="Shape 16">
+            <a:extLst>
+              <a:ext uri="{FF2B5EF4-FFF2-40B4-BE49-F238E27FC236}">
+                <a16:creationId xmlns:a16="http://schemas.microsoft.com/office/drawing/2014/main" id="{065B1783-2806-9226-2026-E44A1B6DA31C}"/>
+              </a:ext>
+            </a:extLst>
+          </p:cNvPr>
+          <p:cNvSpPr/>
+          <p:nvPr/>
+        </p:nvSpPr>
+        <p:spPr>
+          <a:xfrm flipV="1">
+            <a:off x="1545219" y="1933556"/>
+            <a:ext cx="1" cy="1289701"/>
+          </a:xfrm>
+          <a:prstGeom prst="line">
+            <a:avLst/>
+          </a:prstGeom>
+          <a:noFill/>
+          <a:ln w="19050">
+            <a:solidFill>
+              <a:srgbClr val="E94560"/>
+            </a:solidFill>
+            <a:prstDash val="solid"/>
+          </a:ln>
+        </p:spPr>
+        <p:txBody>
+          <a:bodyPr/>
+          <a:lstStyle/>
+          <a:p>
+            <a:endParaRPr lang="en-US"/>
           </a:p>
         </p:txBody>
       </p:sp>
@@ -6921,7 +8571,7 @@
 </p:sld>
 </file>
 
-<file path=ppt/slides/slide7.xml><?xml version="1.0" encoding="utf-8"?>
+<file path=ppt/slides/slide8.xml><?xml version="1.0" encoding="utf-8"?>
 <p:sld xmlns:a="http://schemas.openxmlformats.org/drawingml/2006/main" xmlns:r="http://schemas.openxmlformats.org/officeDocument/2006/relationships" xmlns:p="http://schemas.openxmlformats.org/presentationml/2006/main">
   <p:cSld name="Slide 7">
     <p:bg>
@@ -7876,7 +9526,7 @@
 </p:sld>
 </file>
 
-<file path=ppt/slides/slide8.xml><?xml version="1.0" encoding="utf-8"?>
+<file path=ppt/slides/slide9.xml><?xml version="1.0" encoding="utf-8"?>
 <p:sld xmlns:a="http://schemas.openxmlformats.org/drawingml/2006/main" xmlns:r="http://schemas.openxmlformats.org/officeDocument/2006/relationships" xmlns:p="http://schemas.openxmlformats.org/presentationml/2006/main">
   <p:cSld name="Slide 8">
     <p:bg>
@@ -8253,327 +9903,6 @@
           <a:lstStyle/>
           <a:p>
             <a:endParaRPr lang="en-US"/>
-          </a:p>
-        </p:txBody>
-      </p:sp>
-    </p:spTree>
-  </p:cSld>
-  <p:clrMapOvr>
-    <a:masterClrMapping/>
-  </p:clrMapOvr>
-</p:sld>
-</file>
-
-<file path=ppt/slides/slide9.xml><?xml version="1.0" encoding="utf-8"?>
-<p:sld xmlns:a="http://schemas.openxmlformats.org/drawingml/2006/main" xmlns:r="http://schemas.openxmlformats.org/officeDocument/2006/relationships" xmlns:p="http://schemas.openxmlformats.org/presentationml/2006/main">
-  <p:cSld name="Slide 9">
-    <p:bg>
-      <p:bgPr>
-        <a:solidFill>
-          <a:srgbClr val="0F1624"/>
-        </a:solidFill>
-        <a:effectLst/>
-      </p:bgPr>
-    </p:bg>
-    <p:spTree>
-      <p:nvGrpSpPr>
-        <p:cNvPr id="1" name=""/>
-        <p:cNvGrpSpPr/>
-        <p:nvPr/>
-      </p:nvGrpSpPr>
-      <p:grpSpPr>
-        <a:xfrm>
-          <a:off x="0" y="0"/>
-          <a:ext cx="0" cy="0"/>
-          <a:chOff x="0" y="0"/>
-          <a:chExt cx="0" cy="0"/>
-        </a:xfrm>
-      </p:grpSpPr>
-      <p:sp>
-        <p:nvSpPr>
-          <p:cNvPr id="2" name="Text 0"/>
-          <p:cNvSpPr/>
-          <p:nvPr/>
-        </p:nvSpPr>
-        <p:spPr>
-          <a:xfrm>
-            <a:off x="457200" y="256032"/>
-            <a:ext cx="8229600" cy="594360"/>
-          </a:xfrm>
-          <a:prstGeom prst="rect">
-            <a:avLst/>
-          </a:prstGeom>
-          <a:noFill/>
-          <a:ln/>
-        </p:spPr>
-        <p:txBody>
-          <a:bodyPr wrap="square" lIns="0" tIns="0" rIns="0" bIns="0" rtlCol="0" anchor="ctr"/>
-          <a:lstStyle/>
-          <a:p>
-            <a:pPr marL="0" indent="0" algn="l">
-              <a:buNone/>
-            </a:pPr>
-            <a:r>
-              <a:rPr lang="en-US" sz="3200" b="1" dirty="0">
-                <a:solidFill>
-                  <a:srgbClr val="FFFFFF"/>
-                </a:solidFill>
-                <a:latin typeface="Calibri" pitchFamily="34" charset="0"/>
-                <a:ea typeface="Calibri" pitchFamily="34" charset="-122"/>
-                <a:cs typeface="Calibri" pitchFamily="34" charset="-120"/>
-              </a:rPr>
-              <a:t>Git Repository — Branches &amp; Commits</a:t>
-            </a:r>
-            <a:endParaRPr lang="en-US" sz="3200" dirty="0"/>
-          </a:p>
-        </p:txBody>
-      </p:sp>
-      <p:sp>
-        <p:nvSpPr>
-          <p:cNvPr id="3" name="Shape 1"/>
-          <p:cNvSpPr/>
-          <p:nvPr/>
-        </p:nvSpPr>
-        <p:spPr>
-          <a:xfrm>
-            <a:off x="457200" y="877824"/>
-            <a:ext cx="8229600" cy="22860"/>
-          </a:xfrm>
-          <a:prstGeom prst="rect">
-            <a:avLst/>
-          </a:prstGeom>
-          <a:solidFill>
-            <a:srgbClr val="E94560"/>
-          </a:solidFill>
-          <a:ln w="12700">
-            <a:solidFill>
-              <a:srgbClr val="E94560"/>
-            </a:solidFill>
-            <a:prstDash val="solid"/>
-          </a:ln>
-        </p:spPr>
-        <p:txBody>
-          <a:bodyPr/>
-          <a:lstStyle/>
-          <a:p>
-            <a:endParaRPr lang="en-US"/>
-          </a:p>
-        </p:txBody>
-      </p:sp>
-      <p:sp>
-        <p:nvSpPr>
-          <p:cNvPr id="4" name="Shape 2"/>
-          <p:cNvSpPr/>
-          <p:nvPr/>
-        </p:nvSpPr>
-        <p:spPr>
-          <a:xfrm>
-            <a:off x="457200" y="1051560"/>
-            <a:ext cx="8183880" cy="3040380"/>
-          </a:xfrm>
-          <a:prstGeom prst="rect">
-            <a:avLst/>
-          </a:prstGeom>
-          <a:solidFill>
-            <a:srgbClr val="14213D"/>
-          </a:solidFill>
-          <a:ln w="12700">
-            <a:solidFill>
-              <a:srgbClr val="0D9488"/>
-            </a:solidFill>
-            <a:prstDash val="solid"/>
-          </a:ln>
-        </p:spPr>
-        <p:txBody>
-          <a:bodyPr/>
-          <a:lstStyle/>
-          <a:p>
-            <a:endParaRPr lang="en-US"/>
-          </a:p>
-        </p:txBody>
-      </p:sp>
-      <p:sp>
-        <p:nvSpPr>
-          <p:cNvPr id="5" name="Text 3"/>
-          <p:cNvSpPr/>
-          <p:nvPr/>
-        </p:nvSpPr>
-        <p:spPr>
-          <a:xfrm>
-            <a:off x="457200" y="1051560"/>
-            <a:ext cx="8229600" cy="3474720"/>
-          </a:xfrm>
-          <a:prstGeom prst="rect">
-            <a:avLst/>
-          </a:prstGeom>
-          <a:noFill/>
-          <a:ln/>
-        </p:spPr>
-        <p:txBody>
-          <a:bodyPr wrap="square" lIns="0" tIns="0" rIns="0" bIns="0" rtlCol="0" anchor="ctr"/>
-          <a:lstStyle/>
-          <a:p>
-            <a:pPr marL="0" indent="0" algn="ctr">
-              <a:buNone/>
-            </a:pPr>
-            <a:r>
-              <a:rPr lang="en-US" sz="1600" b="1" dirty="0">
-                <a:solidFill>
-                  <a:srgbClr val="B0BEC5"/>
-                </a:solidFill>
-                <a:latin typeface="Calibri" pitchFamily="34" charset="0"/>
-                <a:ea typeface="Calibri" pitchFamily="34" charset="-122"/>
-                <a:cs typeface="Calibri" pitchFamily="34" charset="-120"/>
-              </a:rPr>
-              <a:t>[ Insert GitHub Network graph screenshot here ]</a:t>
-            </a:r>
-            <a:endParaRPr lang="en-US" sz="1600" dirty="0"/>
-          </a:p>
-          <a:p>
-            <a:pPr marL="0" indent="0" algn="ctr">
-              <a:buNone/>
-            </a:pPr>
-            <a:endParaRPr lang="en-US" sz="1600" dirty="0"/>
-          </a:p>
-          <a:p>
-            <a:pPr marL="0" indent="0" algn="ctr">
-              <a:buNone/>
-            </a:pPr>
-            <a:r>
-              <a:rPr lang="en-US" sz="1300" dirty="0">
-                <a:solidFill>
-                  <a:srgbClr val="B0BEC5"/>
-                </a:solidFill>
-                <a:latin typeface="Calibri" pitchFamily="34" charset="0"/>
-                <a:ea typeface="Calibri" pitchFamily="34" charset="-122"/>
-                <a:cs typeface="Calibri" pitchFamily="34" charset="-120"/>
-              </a:rPr>
-              <a:t>Navigate to: GitHub Repo → Insights → Network</a:t>
-            </a:r>
-            <a:endParaRPr lang="en-US" sz="1600" dirty="0"/>
-          </a:p>
-          <a:p>
-            <a:pPr marL="0" indent="0" algn="ctr">
-              <a:buNone/>
-            </a:pPr>
-            <a:r>
-              <a:rPr lang="en-US" sz="1300" dirty="0">
-                <a:solidFill>
-                  <a:srgbClr val="B0BEC5"/>
-                </a:solidFill>
-                <a:latin typeface="Calibri" pitchFamily="34" charset="0"/>
-                <a:ea typeface="Calibri" pitchFamily="34" charset="-122"/>
-                <a:cs typeface="Calibri" pitchFamily="34" charset="-120"/>
-              </a:rPr>
-              <a:t>Take a screenshot and paste it onto this slide.</a:t>
-            </a:r>
-            <a:endParaRPr lang="en-US" sz="1600" dirty="0"/>
-          </a:p>
-        </p:txBody>
-      </p:sp>
-      <p:sp>
-        <p:nvSpPr>
-          <p:cNvPr id="6" name="Text 4"/>
-          <p:cNvSpPr/>
-          <p:nvPr/>
-        </p:nvSpPr>
-        <p:spPr>
-          <a:xfrm>
-            <a:off x="421840" y="4114068"/>
-            <a:ext cx="8138160" cy="365760"/>
-          </a:xfrm>
-          <a:prstGeom prst="rect">
-            <a:avLst/>
-          </a:prstGeom>
-          <a:noFill/>
-          <a:ln/>
-        </p:spPr>
-        <p:txBody>
-          <a:bodyPr wrap="square" rtlCol="0" anchor="t"/>
-          <a:lstStyle/>
-          <a:p>
-            <a:pPr marL="342900" indent="-342900">
-              <a:spcAft>
-                <a:spcPts val="600"/>
-              </a:spcAft>
-              <a:buSzPct val="100000"/>
-              <a:buChar char="•"/>
-            </a:pPr>
-            <a:r>
-              <a:rPr lang="en-US" sz="1100" dirty="0">
-                <a:solidFill>
-                  <a:srgbClr val="B0BEC5"/>
-                </a:solidFill>
-                <a:latin typeface="Calibri" pitchFamily="34" charset="0"/>
-                <a:ea typeface="Calibri" pitchFamily="34" charset="-122"/>
-                <a:cs typeface="Calibri" pitchFamily="34" charset="-120"/>
-              </a:rPr>
-              <a:t>main — stable production branch</a:t>
-            </a:r>
-            <a:endParaRPr lang="en-US" sz="1100" dirty="0"/>
-          </a:p>
-          <a:p>
-            <a:pPr marL="342900" indent="-342900">
-              <a:spcAft>
-                <a:spcPts val="600"/>
-              </a:spcAft>
-              <a:buSzPct val="100000"/>
-              <a:buChar char="•"/>
-            </a:pPr>
-            <a:r>
-              <a:rPr lang="en-US" sz="1100" dirty="0">
-                <a:solidFill>
-                  <a:srgbClr val="B0BEC5"/>
-                </a:solidFill>
-                <a:latin typeface="Calibri" pitchFamily="34" charset="0"/>
-                <a:ea typeface="Calibri" pitchFamily="34" charset="-122"/>
-                <a:cs typeface="Calibri" pitchFamily="34" charset="-120"/>
-              </a:rPr>
-              <a:t>feature/backend — backend API development</a:t>
-            </a:r>
-            <a:endParaRPr lang="en-US" sz="1100" dirty="0"/>
-          </a:p>
-          <a:p>
-            <a:pPr marL="342900" indent="-342900">
-              <a:spcAft>
-                <a:spcPts val="600"/>
-              </a:spcAft>
-              <a:buSzPct val="100000"/>
-              <a:buChar char="•"/>
-            </a:pPr>
-            <a:r>
-              <a:rPr lang="en-US" sz="1100" dirty="0">
-                <a:solidFill>
-                  <a:srgbClr val="B0BEC5"/>
-                </a:solidFill>
-                <a:latin typeface="Calibri" pitchFamily="34" charset="0"/>
-                <a:ea typeface="Calibri" pitchFamily="34" charset="-122"/>
-                <a:cs typeface="Calibri" pitchFamily="34" charset="-120"/>
-              </a:rPr>
-              <a:t>feature/frontend — React SPA development</a:t>
-            </a:r>
-            <a:endParaRPr lang="en-US" sz="1100" dirty="0"/>
-          </a:p>
-          <a:p>
-            <a:pPr marL="342900" indent="-342900">
-              <a:spcAft>
-                <a:spcPts val="600"/>
-              </a:spcAft>
-              <a:buSzPct val="100000"/>
-              <a:buChar char="•"/>
-            </a:pPr>
-            <a:r>
-              <a:rPr lang="en-US" sz="1100" dirty="0">
-                <a:solidFill>
-                  <a:srgbClr val="B0BEC5"/>
-                </a:solidFill>
-                <a:latin typeface="Calibri" pitchFamily="34" charset="0"/>
-                <a:ea typeface="Calibri" pitchFamily="34" charset="-122"/>
-                <a:cs typeface="Calibri" pitchFamily="34" charset="-120"/>
-              </a:rPr>
-              <a:t>fix/* — bug fix branches merged into main via PR</a:t>
-            </a:r>
-            <a:endParaRPr lang="en-US" sz="1100" dirty="0"/>
           </a:p>
         </p:txBody>
       </p:sp>

</xml_diff>